<commit_message>
Update Content-Based Filtering with CountVectorizer and Cosine Similarity, and add Title 1 - Introduction presentation slide
</commit_message>
<xml_diff>
--- a/ANIVIBE_Presentation.pptx
+++ b/ANIVIBE_Presentation.pptx
@@ -21,6 +21,7 @@
     <p:sldId id="269" r:id="rId20"/>
     <p:sldId id="270" r:id="rId21"/>
     <p:sldId id="271" r:id="rId22"/>
+    <p:sldId id="272" r:id="rId23"/>
   </p:sldIdLst>
   <p:sldSz cx="12191695" cy="6858000" type="screen4x3"/>
   <p:notesSz cx="6858000" cy="9144000"/>
@@ -3430,7 +3431,7 @@
               </a:defRPr>
             </a:pPr>
             <a:r>
-              <a:t>RECOMMENDATION PARADIGM 3B</a:t>
+              <a:t>RECOMMENDATION PARADIGM 3A</a:t>
             </a:r>
           </a:p>
         </p:txBody>
@@ -3466,7 +3467,7 @@
               </a:defRPr>
             </a:pPr>
             <a:r>
-              <a:t>Viewing Mood &amp; Explainable AI</a:t>
+              <a:t>Knowledge-Based Decision Constraints</a:t>
             </a:r>
           </a:p>
         </p:txBody>
@@ -3502,7 +3503,7 @@
               </a:defRPr>
             </a:pPr>
             <a:r>
-              <a:t>Mapping emotional mood to genres and providing transparent reasoning checklists.</a:t>
+              <a:t>Evaluating user situation limits through hard constraint satisfaction.</a:t>
             </a:r>
           </a:p>
         </p:txBody>
@@ -3526,7 +3527,7 @@
           </a:solidFill>
           <a:ln w="19050">
             <a:solidFill>
-              <a:srgbClr val="A855F7"/>
+              <a:srgbClr val="06B6D4"/>
             </a:solidFill>
           </a:ln>
         </p:spPr>
@@ -3585,13 +3586,13 @@
               </a:defRPr>
             </a:pPr>
             <a:r>
-              <a:t>Mood-to-Genre Domain Mapping</a:t>
-            </a:r>
-          </a:p>
-          <a:p>
-            <a:pPr>
-              <a:spcAft>
-                <a:spcPts val="1000"/>
+              <a:t>Explicit Hard Constraints</a:t>
+            </a:r>
+          </a:p>
+          <a:p>
+            <a:pPr>
+              <a:spcAft>
+                <a:spcPts val="1200"/>
               </a:spcAft>
               <a:defRPr sz="1800">
                 <a:solidFill>
@@ -3600,13 +3601,13 @@
               </a:defRPr>
             </a:pPr>
             <a:r>
-              <a:t>•  Exciting Mood: Action, Shonen, Tournament, Super Power, Martial Arts.</a:t>
-            </a:r>
-          </a:p>
-          <a:p>
-            <a:pPr>
-              <a:spcAft>
-                <a:spcPts val="1000"/>
+              <a:t>•  Episode Budget Limit: Candidate must have episodes ≤ user limit (e.g. ≤ 13 eps for a single evening).</a:t>
+            </a:r>
+          </a:p>
+          <a:p>
+            <a:pPr>
+              <a:spcAft>
+                <a:spcPts val="1200"/>
               </a:spcAft>
               <a:defRPr sz="1800">
                 <a:solidFill>
@@ -3615,13 +3616,13 @@
               </a:defRPr>
             </a:pPr>
             <a:r>
-              <a:t>•  Chill Mood: Slice of Life, Comedy, Light Romance.</a:t>
-            </a:r>
-          </a:p>
-          <a:p>
-            <a:pPr>
-              <a:spcAft>
-                <a:spcPts val="1000"/>
+              <a:t>•  Minimum Quality Threshold: Candidate must have viewer score ≥ user minimum (e.g. rating ≥ 4.0★).</a:t>
+            </a:r>
+          </a:p>
+          <a:p>
+            <a:pPr>
+              <a:spcAft>
+                <a:spcPts val="1200"/>
               </a:spcAft>
               <a:defRPr sz="1800">
                 <a:solidFill>
@@ -3630,13 +3631,13 @@
               </a:defRPr>
             </a:pPr>
             <a:r>
-              <a:t>•  Dark Mood: Psychological, Thriller, Horror, Mystery.</a:t>
-            </a:r>
-          </a:p>
-          <a:p>
-            <a:pPr>
-              <a:spcAft>
-                <a:spcPts val="1000"/>
+              <a:t>•  Required Genres: Candidate must include all selected required genres (e.g. must include Sci-Fi).</a:t>
+            </a:r>
+          </a:p>
+          <a:p>
+            <a:pPr>
+              <a:spcAft>
+                <a:spcPts val="1200"/>
               </a:spcAft>
               <a:defRPr sz="1800">
                 <a:solidFill>
@@ -3645,22 +3646,7 @@
               </a:defRPr>
             </a:pPr>
             <a:r>
-              <a:t>•  Emotional Mood: Drama, Romance, Emotional Slice of Life.</a:t>
-            </a:r>
-          </a:p>
-          <a:p>
-            <a:pPr>
-              <a:spcAft>
-                <a:spcPts val="1000"/>
-              </a:spcAft>
-              <a:defRPr sz="1800">
-                <a:solidFill>
-                  <a:srgbClr val="E2E8F0"/>
-                </a:solidFill>
-              </a:defRPr>
-            </a:pPr>
-            <a:r>
-              <a:t>•  Soft Multiplier: Mood match provides an additive score bonus (+0.15) to boost candidate ranking.</a:t>
+              <a:t>•  Excluded Genres: Candidate must NOT contain any forbidden genres (e.g. avoid Horror).</a:t>
             </a:r>
           </a:p>
         </p:txBody>
@@ -3684,7 +3670,7 @@
           </a:solidFill>
           <a:ln w="19050">
             <a:solidFill>
-              <a:srgbClr val="10B981"/>
+              <a:srgbClr val="334155"/>
             </a:solidFill>
           </a:ln>
         </p:spPr>
@@ -3743,13 +3729,13 @@
               </a:defRPr>
             </a:pPr>
             <a:r>
-              <a:t>Transparent Explainable AI (XAI)</a:t>
-            </a:r>
-          </a:p>
-          <a:p>
-            <a:pPr>
-              <a:spcAft>
-                <a:spcPts val="1000"/>
+              <a:t>Domain Knowledge Rules</a:t>
+            </a:r>
+          </a:p>
+          <a:p>
+            <a:pPr>
+              <a:spcAft>
+                <a:spcPts val="1200"/>
               </a:spcAft>
               <a:defRPr sz="1800">
                 <a:solidFill>
@@ -3758,13 +3744,25 @@
               </a:defRPr>
             </a:pPr>
             <a:r>
-              <a:t>•  Zero Black-Box Decisions: Users are never left wondering why an anime appeared.</a:t>
-            </a:r>
-          </a:p>
-          <a:p>
-            <a:pPr>
-              <a:spcAft>
-                <a:spcPts val="1000"/>
+              <a:t>•  Viewing Commitment Rule: Categorizes anime length into clear commitment tiers:</a:t>
+            </a:r>
+            <a:br/>
+            <a:r>
+              <a:t>   - Short: ≤ 13 episodes (quick finish)</a:t>
+            </a:r>
+            <a:br/>
+            <a:r>
+              <a:t>   - Medium: 14 to 26 episodes (weekend binge)</a:t>
+            </a:r>
+            <a:br/>
+            <a:r>
+              <a:t>   - Long: &gt; 26 episodes (extended series)</a:t>
+            </a:r>
+          </a:p>
+          <a:p>
+            <a:pPr>
+              <a:spcAft>
+                <a:spcPts val="1200"/>
               </a:spcAft>
               <a:defRPr sz="1800">
                 <a:solidFill>
@@ -3773,25 +3771,13 @@
               </a:defRPr>
             </a:pPr>
             <a:r>
-              <a:t>•  Transparent Evaluation Checklist: Every title displays a clear verdict table:</a:t>
-            </a:r>
-            <a:br/>
-            <a:r>
-              <a:t>   - Episode Limit: Target ≤ 26 vs Actual 12 eps (Passed)</a:t>
-            </a:r>
-            <a:br/>
-            <a:r>
-              <a:t>   - Quality Score: Target ≥ 4.0 vs Actual 4.3★ (Passed)</a:t>
-            </a:r>
-            <a:br/>
-            <a:r>
-              <a:t>   - Mood Overlap: Matched 'Action, Shonen' (Passed)</a:t>
-            </a:r>
-          </a:p>
-          <a:p>
-            <a:pPr>
-              <a:spcAft>
-                <a:spcPts val="1000"/>
+              <a:t>•  Zero Past History Needed: Functions as an on-demand decision filter; works 100% on day one.</a:t>
+            </a:r>
+          </a:p>
+          <a:p>
+            <a:pPr>
+              <a:spcAft>
+                <a:spcPts val="1200"/>
               </a:spcAft>
               <a:defRPr sz="1800">
                 <a:solidFill>
@@ -3800,7 +3786,7 @@
               </a:defRPr>
             </a:pPr>
             <a:r>
-              <a:t>•  Builds User Trust: Explaining the reasoning boosts viewer confidence in recommendations.</a:t>
+              <a:t>•  High Utility Focus: Guarantees that every returned title strictly fits the user's available time.</a:t>
             </a:r>
           </a:p>
         </p:txBody>
@@ -3897,7 +3883,7 @@
               </a:defRPr>
             </a:pPr>
             <a:r>
-              <a:t>RECOMMENDATION PARADIGM 4A</a:t>
+              <a:t>RECOMMENDATION PARADIGM 3B</a:t>
             </a:r>
           </a:p>
         </p:txBody>
@@ -3933,7 +3919,7 @@
               </a:defRPr>
             </a:pPr>
             <a:r>
-              <a:t>1+1 Hybrid Fusion ('Smart Match')</a:t>
+              <a:t>Viewing Mood &amp; Explainable AI</a:t>
             </a:r>
           </a:p>
         </p:txBody>
@@ -3969,7 +3955,7 @@
               </a:defRPr>
             </a:pPr>
             <a:r>
-              <a:t>Balancing personal taste with situational constraints in a unified mathematical model.</a:t>
+              <a:t>Mapping emotional mood to genres and providing transparent reasoning checklists.</a:t>
             </a:r>
           </a:p>
         </p:txBody>
@@ -3993,7 +3979,7 @@
           </a:solidFill>
           <a:ln w="19050">
             <a:solidFill>
-              <a:srgbClr val="6366F1"/>
+              <a:srgbClr val="A855F7"/>
             </a:solidFill>
           </a:ln>
         </p:spPr>
@@ -4043,7 +4029,7 @@
           <a:p>
             <a:pPr>
               <a:spcAft>
-                <a:spcPts val="1400"/>
+                <a:spcPts val="1600"/>
               </a:spcAft>
               <a:defRPr sz="2400" b="1">
                 <a:solidFill>
@@ -4052,28 +4038,13 @@
               </a:defRPr>
             </a:pPr>
             <a:r>
-              <a:t>The Hybrid Formula</a:t>
-            </a:r>
-          </a:p>
-          <a:p>
-            <a:pPr>
-              <a:spcAft>
-                <a:spcPts val="1600"/>
-              </a:spcAft>
-              <a:defRPr sz="2000" b="1">
-                <a:solidFill>
-                  <a:srgbClr val="06B6D4"/>
-                </a:solidFill>
-              </a:defRPr>
-            </a:pPr>
-            <a:r>
-              <a:t>Score_Hybrid = 0.50 × S_CBF + 0.50 × S_KBR</a:t>
-            </a:r>
-          </a:p>
-          <a:p>
-            <a:pPr>
-              <a:spcAft>
-                <a:spcPts val="1200"/>
+              <a:t>Mood-to-Genre Domain Mapping</a:t>
+            </a:r>
+          </a:p>
+          <a:p>
+            <a:pPr>
+              <a:spcAft>
+                <a:spcPts val="1000"/>
               </a:spcAft>
               <a:defRPr sz="1800">
                 <a:solidFill>
@@ -4082,13 +4053,13 @@
               </a:defRPr>
             </a:pPr>
             <a:r>
-              <a:t>•  50% User Taste (S_CBF): Cosine similarity between candidate anime and the user's rated genre profile.</a:t>
-            </a:r>
-          </a:p>
-          <a:p>
-            <a:pPr>
-              <a:spcAft>
-                <a:spcPts val="1200"/>
+              <a:t>•  Exciting Mood: Action, Shonen, Tournament, Super Power, Martial Arts.</a:t>
+            </a:r>
+          </a:p>
+          <a:p>
+            <a:pPr>
+              <a:spcAft>
+                <a:spcPts val="1000"/>
               </a:spcAft>
               <a:defRPr sz="1800">
                 <a:solidFill>
@@ -4097,13 +4068,13 @@
               </a:defRPr>
             </a:pPr>
             <a:r>
-              <a:t>•  50% Requirement Fit (S_KBR): Continuous utility score reflecting episode fit, score bonus, and mood overlap.</a:t>
-            </a:r>
-          </a:p>
-          <a:p>
-            <a:pPr>
-              <a:spcAft>
-                <a:spcPts val="1200"/>
+              <a:t>•  Chill Mood: Slice of Life, Comedy, Light Romance.</a:t>
+            </a:r>
+          </a:p>
+          <a:p>
+            <a:pPr>
+              <a:spcAft>
+                <a:spcPts val="1000"/>
               </a:spcAft>
               <a:defRPr sz="1800">
                 <a:solidFill>
@@ -4112,7 +4083,37 @@
               </a:defRPr>
             </a:pPr>
             <a:r>
-              <a:t>•  Multi-Dimensional Scoring: Displays both individual match percentages (Taste % and Constraint %) alongside overall Hybrid Match %.</a:t>
+              <a:t>•  Dark Mood: Psychological, Thriller, Horror, Mystery.</a:t>
+            </a:r>
+          </a:p>
+          <a:p>
+            <a:pPr>
+              <a:spcAft>
+                <a:spcPts val="1000"/>
+              </a:spcAft>
+              <a:defRPr sz="1800">
+                <a:solidFill>
+                  <a:srgbClr val="E2E8F0"/>
+                </a:solidFill>
+              </a:defRPr>
+            </a:pPr>
+            <a:r>
+              <a:t>•  Emotional Mood: Drama, Romance, Emotional Slice of Life.</a:t>
+            </a:r>
+          </a:p>
+          <a:p>
+            <a:pPr>
+              <a:spcAft>
+                <a:spcPts val="1000"/>
+              </a:spcAft>
+              <a:defRPr sz="1800">
+                <a:solidFill>
+                  <a:srgbClr val="E2E8F0"/>
+                </a:solidFill>
+              </a:defRPr>
+            </a:pPr>
+            <a:r>
+              <a:t>•  Soft Multiplier: Mood match provides an additive score bonus (+0.15) to boost candidate ranking.</a:t>
             </a:r>
           </a:p>
         </p:txBody>
@@ -4136,7 +4137,7 @@
           </a:solidFill>
           <a:ln w="19050">
             <a:solidFill>
-              <a:srgbClr val="334155"/>
+              <a:srgbClr val="10B981"/>
             </a:solidFill>
           </a:ln>
         </p:spPr>
@@ -4195,13 +4196,13 @@
               </a:defRPr>
             </a:pPr>
             <a:r>
-              <a:t>Why Both Components Are Vital</a:t>
-            </a:r>
-          </a:p>
-          <a:p>
-            <a:pPr>
-              <a:spcAft>
-                <a:spcPts val="1400"/>
+              <a:t>Transparent Explainable AI (XAI)</a:t>
+            </a:r>
+          </a:p>
+          <a:p>
+            <a:pPr>
+              <a:spcAft>
+                <a:spcPts val="1000"/>
               </a:spcAft>
               <a:defRPr sz="1800">
                 <a:solidFill>
@@ -4210,13 +4211,13 @@
               </a:defRPr>
             </a:pPr>
             <a:r>
-              <a:t>•  Taste Alone is Incomplete: A show may match your taste 100%, but if it has 500 episodes when you only have tonight, it is useless.</a:t>
-            </a:r>
-          </a:p>
-          <a:p>
-            <a:pPr>
-              <a:spcAft>
-                <a:spcPts val="1400"/>
+              <a:t>•  Zero Black-Box Decisions: Users are never left wondering why an anime appeared.</a:t>
+            </a:r>
+          </a:p>
+          <a:p>
+            <a:pPr>
+              <a:spcAft>
+                <a:spcPts val="1000"/>
               </a:spcAft>
               <a:defRPr sz="1800">
                 <a:solidFill>
@@ -4225,13 +4226,25 @@
               </a:defRPr>
             </a:pPr>
             <a:r>
-              <a:t>•  Constraints Alone Lack Flavor: A filter alone might find a 12-episode show with 4.5★, but in a genre you completely dislike.</a:t>
-            </a:r>
-          </a:p>
-          <a:p>
-            <a:pPr>
-              <a:spcAft>
-                <a:spcPts val="1400"/>
+              <a:t>•  Transparent Evaluation Checklist: Every title displays a clear verdict table:</a:t>
+            </a:r>
+            <a:br/>
+            <a:r>
+              <a:t>   - Episode Limit: Target ≤ 26 vs Actual 12 eps (Passed)</a:t>
+            </a:r>
+            <a:br/>
+            <a:r>
+              <a:t>   - Quality Score: Target ≥ 4.0 vs Actual 4.3★ (Passed)</a:t>
+            </a:r>
+            <a:br/>
+            <a:r>
+              <a:t>   - Mood Overlap: Matched 'Action, Shonen' (Passed)</a:t>
+            </a:r>
+          </a:p>
+          <a:p>
+            <a:pPr>
+              <a:spcAft>
+                <a:spcPts val="1000"/>
               </a:spcAft>
               <a:defRPr sz="1800">
                 <a:solidFill>
@@ -4240,7 +4253,7 @@
               </a:defRPr>
             </a:pPr>
             <a:r>
-              <a:t>•  The Synergy: The 1+1 Hybrid guarantees that every top recommendation is both genuinely loved AND realistically watchable right now.</a:t>
+              <a:t>•  Builds User Trust: Explaining the reasoning boosts viewer confidence in recommendations.</a:t>
             </a:r>
           </a:p>
         </p:txBody>
@@ -4337,7 +4350,7 @@
               </a:defRPr>
             </a:pPr>
             <a:r>
-              <a:t>RECOMMENDATION PARADIGM 4B</a:t>
+              <a:t>RECOMMENDATION PARADIGM 4A</a:t>
             </a:r>
           </a:p>
         </p:txBody>
@@ -4373,7 +4386,7 @@
               </a:defRPr>
             </a:pPr>
             <a:r>
-              <a:t>Cold-Start Handling &amp; Diversity</a:t>
+              <a:t>1+1 Hybrid Fusion ('Smart Match')</a:t>
             </a:r>
           </a:p>
         </p:txBody>
@@ -4409,7 +4422,7 @@
               </a:defRPr>
             </a:pPr>
             <a:r>
-              <a:t>Switching hybrid architecture that eliminates cold-start crashes and overspecialization.</a:t>
+              <a:t>Balancing personal taste with situational constraints in a unified mathematical model.</a:t>
             </a:r>
           </a:p>
         </p:txBody>
@@ -4433,7 +4446,7 @@
           </a:solidFill>
           <a:ln w="19050">
             <a:solidFill>
-              <a:srgbClr val="10B981"/>
+              <a:srgbClr val="6366F1"/>
             </a:solidFill>
           </a:ln>
         </p:spPr>
@@ -4483,16 +4496,31 @@
           <a:p>
             <a:pPr>
               <a:spcAft>
+                <a:spcPts val="1400"/>
+              </a:spcAft>
+              <a:defRPr sz="2400" b="1">
+                <a:solidFill>
+                  <a:srgbClr val="F8FAFC"/>
+                </a:solidFill>
+              </a:defRPr>
+            </a:pPr>
+            <a:r>
+              <a:t>The Hybrid Formula</a:t>
+            </a:r>
+          </a:p>
+          <a:p>
+            <a:pPr>
+              <a:spcAft>
                 <a:spcPts val="1600"/>
               </a:spcAft>
-              <a:defRPr sz="2400" b="1">
-                <a:solidFill>
-                  <a:srgbClr val="F8FAFC"/>
-                </a:solidFill>
-              </a:defRPr>
-            </a:pPr>
-            <a:r>
-              <a:t>Graceful Cold-Start Strategy</a:t>
+              <a:defRPr sz="2000" b="1">
+                <a:solidFill>
+                  <a:srgbClr val="06B6D4"/>
+                </a:solidFill>
+              </a:defRPr>
+            </a:pPr>
+            <a:r>
+              <a:t>Score_Hybrid = 0.50 × S_CBF + 0.50 × S_KBR</a:t>
             </a:r>
           </a:p>
           <a:p>
@@ -4507,7 +4535,7 @@
               </a:defRPr>
             </a:pPr>
             <a:r>
-              <a:t>•  0 Ratings Detection: When a visitor has not rated any titles, Smart Match detects cold-start immediately.</a:t>
+              <a:t>•  50% User Taste (S_CBF): Cosine similarity between candidate anime and the user's rated genre profile.</a:t>
             </a:r>
           </a:p>
           <a:p>
@@ -4522,7 +4550,7 @@
               </a:defRPr>
             </a:pPr>
             <a:r>
-              <a:t>•  Interactive Onboarding: Shows a clean banner prompting the user to rate 2 or 3 titles to unlock taste scoring.</a:t>
+              <a:t>•  50% Requirement Fit (S_KBR): Continuous utility score reflecting episode fit, score bonus, and mood overlap.</a:t>
             </a:r>
           </a:p>
           <a:p>
@@ -4537,22 +4565,7 @@
               </a:defRPr>
             </a:pPr>
             <a:r>
-              <a:t>•  Switching Fallback: Seamlessly routes queries through Knowledge-Based constraint filters without throwing errors.</a:t>
-            </a:r>
-          </a:p>
-          <a:p>
-            <a:pPr>
-              <a:spcAft>
-                <a:spcPts val="1200"/>
-              </a:spcAft>
-              <a:defRPr sz="1800">
-                <a:solidFill>
-                  <a:srgbClr val="E2E8F0"/>
-                </a:solidFill>
-              </a:defRPr>
-            </a:pPr>
-            <a:r>
-              <a:t>•  Zero System Crashes: Ensures 100% stability regardless of whether the user is brand new or an experienced rater.</a:t>
+              <a:t>•  Multi-Dimensional Scoring: Displays both individual match percentages (Taste % and Constraint %) alongside overall Hybrid Match %.</a:t>
             </a:r>
           </a:p>
         </p:txBody>
@@ -4576,7 +4589,7 @@
           </a:solidFill>
           <a:ln w="19050">
             <a:solidFill>
-              <a:srgbClr val="A855F7"/>
+              <a:srgbClr val="334155"/>
             </a:solidFill>
           </a:ln>
         </p:spPr>
@@ -4635,13 +4648,13 @@
               </a:defRPr>
             </a:pPr>
             <a:r>
-              <a:t>Overcoming Overspecialization</a:t>
-            </a:r>
-          </a:p>
-          <a:p>
-            <a:pPr>
-              <a:spcAft>
-                <a:spcPts val="1200"/>
+              <a:t>Why Both Components Are Vital</a:t>
+            </a:r>
+          </a:p>
+          <a:p>
+            <a:pPr>
+              <a:spcAft>
+                <a:spcPts val="1400"/>
               </a:spcAft>
               <a:defRPr sz="1800">
                 <a:solidFill>
@@ -4650,13 +4663,13 @@
               </a:defRPr>
             </a:pPr>
             <a:r>
-              <a:t>•  The Echo Chamber Problem: Pure Content-Based recommenders suffer from low diversity (0.1334), trapping users in one genre.</a:t>
-            </a:r>
-          </a:p>
-          <a:p>
-            <a:pPr>
-              <a:spcAft>
-                <a:spcPts val="1200"/>
+              <a:t>•  Taste Alone is Incomplete: A show may match your taste 100%, but if it has 500 episodes when you only have tonight, it is useless.</a:t>
+            </a:r>
+          </a:p>
+          <a:p>
+            <a:pPr>
+              <a:spcAft>
+                <a:spcPts val="1400"/>
               </a:spcAft>
               <a:defRPr sz="1800">
                 <a:solidFill>
@@ -4665,13 +4678,13 @@
               </a:defRPr>
             </a:pPr>
             <a:r>
-              <a:t>•  Healthy Serendipity: Knowledge constraints (mood, length) pull candidates from neighboring genres that still fit the situation.</a:t>
-            </a:r>
-          </a:p>
-          <a:p>
-            <a:pPr>
-              <a:spcAft>
-                <a:spcPts val="1200"/>
+              <a:t>•  Constraints Alone Lack Flavor: A filter alone might find a 12-episode show with 4.5★, but in a genre you completely dislike.</a:t>
+            </a:r>
+          </a:p>
+          <a:p>
+            <a:pPr>
+              <a:spcAft>
+                <a:spcPts val="1400"/>
               </a:spcAft>
               <a:defRPr sz="1800">
                 <a:solidFill>
@@ -4680,22 +4693,7 @@
               </a:defRPr>
             </a:pPr>
             <a:r>
-              <a:t>•  +51% Diversity Improvement: The 1+1 Hybrid increases recommendation diversity from 0.1334 to 0.2017.</a:t>
-            </a:r>
-          </a:p>
-          <a:p>
-            <a:pPr>
-              <a:spcAft>
-                <a:spcPts val="1200"/>
-              </a:spcAft>
-              <a:defRPr sz="1800">
-                <a:solidFill>
-                  <a:srgbClr val="E2E8F0"/>
-                </a:solidFill>
-              </a:defRPr>
-            </a:pPr>
-            <a:r>
-              <a:t>•  Best of Both Worlds: Delivers fresh variety while preserving 100% relevance to the user's current needs.</a:t>
+              <a:t>•  The Synergy: The 1+1 Hybrid guarantees that every top recommendation is both genuinely loved AND realistically watchable right now.</a:t>
             </a:r>
           </a:p>
         </p:txBody>
@@ -4709,6 +4707,461 @@
 </file>
 
 <file path=ppt/slides/slide13.xml><?xml version="1.0" encoding="utf-8"?>
+<p:sld xmlns:a="http://schemas.openxmlformats.org/drawingml/2006/main" xmlns:p="http://schemas.openxmlformats.org/presentationml/2006/main" xmlns:r="http://schemas.openxmlformats.org/officeDocument/2006/relationships">
+  <p:cSld>
+    <p:spTree>
+      <p:nvGrpSpPr>
+        <p:cNvPr id="1" name=""/>
+        <p:cNvGrpSpPr/>
+        <p:nvPr/>
+      </p:nvGrpSpPr>
+      <p:grpSpPr/>
+      <p:sp>
+        <p:nvSpPr>
+          <p:cNvPr id="2" name="Rectangle 1"/>
+          <p:cNvSpPr/>
+          <p:nvPr/>
+        </p:nvSpPr>
+        <p:spPr>
+          <a:xfrm>
+            <a:off x="0" y="0"/>
+            <a:ext cx="12191695" cy="6858000"/>
+          </a:xfrm>
+          <a:prstGeom prst="rect">
+            <a:avLst/>
+          </a:prstGeom>
+          <a:solidFill>
+            <a:srgbClr val="0F172A"/>
+          </a:solidFill>
+          <a:ln>
+            <a:noFill/>
+          </a:ln>
+        </p:spPr>
+        <p:style>
+          <a:lnRef idx="1">
+            <a:schemeClr val="accent1"/>
+          </a:lnRef>
+          <a:fillRef idx="3">
+            <a:schemeClr val="accent1"/>
+          </a:fillRef>
+          <a:effectRef idx="2">
+            <a:schemeClr val="accent1"/>
+          </a:effectRef>
+          <a:fontRef idx="minor">
+            <a:schemeClr val="lt1"/>
+          </a:fontRef>
+        </p:style>
+        <p:txBody>
+          <a:bodyPr rtlCol="0" anchor="ctr"/>
+          <a:lstStyle/>
+          <a:p>
+            <a:pPr algn="ctr"/>
+          </a:p>
+        </p:txBody>
+      </p:sp>
+      <p:sp>
+        <p:nvSpPr>
+          <p:cNvPr id="3" name="TextBox 2"/>
+          <p:cNvSpPr txBox="1"/>
+          <p:nvPr/>
+        </p:nvSpPr>
+        <p:spPr>
+          <a:xfrm>
+            <a:off x="731520" y="320040"/>
+            <a:ext cx="10698480" cy="320040"/>
+          </a:xfrm>
+          <a:prstGeom prst="rect">
+            <a:avLst/>
+          </a:prstGeom>
+          <a:noFill/>
+        </p:spPr>
+        <p:txBody>
+          <a:bodyPr wrap="square" lIns="0" tIns="0" rIns="0" bIns="0">
+            <a:spAutoFit/>
+          </a:bodyPr>
+          <a:lstStyle/>
+          <a:p>
+            <a:pPr>
+              <a:defRPr sz="1800" b="1">
+                <a:solidFill>
+                  <a:srgbClr val="6366F1"/>
+                </a:solidFill>
+                <a:latin typeface="Arial"/>
+              </a:defRPr>
+            </a:pPr>
+            <a:r>
+              <a:t>RECOMMENDATION PARADIGM 4B</a:t>
+            </a:r>
+          </a:p>
+        </p:txBody>
+      </p:sp>
+      <p:sp>
+        <p:nvSpPr>
+          <p:cNvPr id="4" name="TextBox 3"/>
+          <p:cNvSpPr txBox="1"/>
+          <p:nvPr/>
+        </p:nvSpPr>
+        <p:spPr>
+          <a:xfrm>
+            <a:off x="731520" y="685800"/>
+            <a:ext cx="10698480" cy="594360"/>
+          </a:xfrm>
+          <a:prstGeom prst="rect">
+            <a:avLst/>
+          </a:prstGeom>
+          <a:noFill/>
+        </p:spPr>
+        <p:txBody>
+          <a:bodyPr wrap="square" lIns="0" tIns="0" rIns="0" bIns="0">
+            <a:spAutoFit/>
+          </a:bodyPr>
+          <a:lstStyle/>
+          <a:p>
+            <a:pPr>
+              <a:defRPr sz="3200" b="1">
+                <a:solidFill>
+                  <a:srgbClr val="F8FAFC"/>
+                </a:solidFill>
+                <a:latin typeface="Helvetica"/>
+              </a:defRPr>
+            </a:pPr>
+            <a:r>
+              <a:t>Cold-Start Handling &amp; Diversity</a:t>
+            </a:r>
+          </a:p>
+        </p:txBody>
+      </p:sp>
+      <p:sp>
+        <p:nvSpPr>
+          <p:cNvPr id="5" name="TextBox 4"/>
+          <p:cNvSpPr txBox="1"/>
+          <p:nvPr/>
+        </p:nvSpPr>
+        <p:spPr>
+          <a:xfrm>
+            <a:off x="731520" y="1298448"/>
+            <a:ext cx="10698480" cy="411480"/>
+          </a:xfrm>
+          <a:prstGeom prst="rect">
+            <a:avLst/>
+          </a:prstGeom>
+          <a:noFill/>
+        </p:spPr>
+        <p:txBody>
+          <a:bodyPr wrap="square" lIns="0" tIns="0" rIns="0" bIns="0">
+            <a:spAutoFit/>
+          </a:bodyPr>
+          <a:lstStyle/>
+          <a:p>
+            <a:pPr>
+              <a:defRPr sz="2000">
+                <a:solidFill>
+                  <a:srgbClr val="94A3B8"/>
+                </a:solidFill>
+                <a:latin typeface="Arial"/>
+              </a:defRPr>
+            </a:pPr>
+            <a:r>
+              <a:t>Switching hybrid architecture that eliminates cold-start crashes and overspecialization.</a:t>
+            </a:r>
+          </a:p>
+        </p:txBody>
+      </p:sp>
+      <p:sp>
+        <p:nvSpPr>
+          <p:cNvPr id="6" name="Rounded Rectangle 5"/>
+          <p:cNvSpPr/>
+          <p:nvPr/>
+        </p:nvSpPr>
+        <p:spPr>
+          <a:xfrm>
+            <a:off x="731520" y="1965960"/>
+            <a:ext cx="5166360" cy="2011680"/>
+          </a:xfrm>
+          <a:prstGeom prst="roundRect">
+            <a:avLst/>
+          </a:prstGeom>
+          <a:solidFill>
+            <a:srgbClr val="1E293B"/>
+          </a:solidFill>
+          <a:ln w="19050">
+            <a:solidFill>
+              <a:srgbClr val="10B981"/>
+            </a:solidFill>
+          </a:ln>
+        </p:spPr>
+        <p:style>
+          <a:lnRef idx="1">
+            <a:schemeClr val="accent1"/>
+          </a:lnRef>
+          <a:fillRef idx="3">
+            <a:schemeClr val="accent1"/>
+          </a:fillRef>
+          <a:effectRef idx="2">
+            <a:schemeClr val="accent1"/>
+          </a:effectRef>
+          <a:fontRef idx="minor">
+            <a:schemeClr val="lt1"/>
+          </a:fontRef>
+        </p:style>
+        <p:txBody>
+          <a:bodyPr rtlCol="0" anchor="ctr"/>
+          <a:lstStyle/>
+          <a:p>
+            <a:pPr algn="ctr"/>
+          </a:p>
+        </p:txBody>
+      </p:sp>
+      <p:sp>
+        <p:nvSpPr>
+          <p:cNvPr id="7" name="TextBox 6"/>
+          <p:cNvSpPr txBox="1"/>
+          <p:nvPr/>
+        </p:nvSpPr>
+        <p:spPr>
+          <a:xfrm>
+            <a:off x="1005840" y="2286000"/>
+            <a:ext cx="4617720" cy="1371600"/>
+          </a:xfrm>
+          <a:prstGeom prst="rect">
+            <a:avLst/>
+          </a:prstGeom>
+          <a:noFill/>
+        </p:spPr>
+        <p:txBody>
+          <a:bodyPr wrap="square">
+            <a:spAutoFit/>
+          </a:bodyPr>
+          <a:lstStyle/>
+          <a:p>
+            <a:pPr>
+              <a:spcAft>
+                <a:spcPts val="1600"/>
+              </a:spcAft>
+              <a:defRPr sz="2400" b="1">
+                <a:solidFill>
+                  <a:srgbClr val="F8FAFC"/>
+                </a:solidFill>
+              </a:defRPr>
+            </a:pPr>
+            <a:r>
+              <a:t>Graceful Cold-Start Strategy</a:t>
+            </a:r>
+          </a:p>
+          <a:p>
+            <a:pPr>
+              <a:spcAft>
+                <a:spcPts val="1200"/>
+              </a:spcAft>
+              <a:defRPr sz="1800">
+                <a:solidFill>
+                  <a:srgbClr val="E2E8F0"/>
+                </a:solidFill>
+              </a:defRPr>
+            </a:pPr>
+            <a:r>
+              <a:t>•  0 Ratings Detection: When a visitor has not rated any titles, Smart Match detects cold-start immediately.</a:t>
+            </a:r>
+          </a:p>
+          <a:p>
+            <a:pPr>
+              <a:spcAft>
+                <a:spcPts val="1200"/>
+              </a:spcAft>
+              <a:defRPr sz="1800">
+                <a:solidFill>
+                  <a:srgbClr val="E2E8F0"/>
+                </a:solidFill>
+              </a:defRPr>
+            </a:pPr>
+            <a:r>
+              <a:t>•  Interactive Onboarding: Shows a clean banner prompting the user to rate 2 or 3 titles to unlock taste scoring.</a:t>
+            </a:r>
+          </a:p>
+          <a:p>
+            <a:pPr>
+              <a:spcAft>
+                <a:spcPts val="1200"/>
+              </a:spcAft>
+              <a:defRPr sz="1800">
+                <a:solidFill>
+                  <a:srgbClr val="E2E8F0"/>
+                </a:solidFill>
+              </a:defRPr>
+            </a:pPr>
+            <a:r>
+              <a:t>•  Switching Fallback: Seamlessly routes queries through Knowledge-Based constraint filters without throwing errors.</a:t>
+            </a:r>
+          </a:p>
+          <a:p>
+            <a:pPr>
+              <a:spcAft>
+                <a:spcPts val="1200"/>
+              </a:spcAft>
+              <a:defRPr sz="1800">
+                <a:solidFill>
+                  <a:srgbClr val="E2E8F0"/>
+                </a:solidFill>
+              </a:defRPr>
+            </a:pPr>
+            <a:r>
+              <a:t>•  Zero System Crashes: Ensures 100% stability regardless of whether the user is brand new or an experienced rater.</a:t>
+            </a:r>
+          </a:p>
+        </p:txBody>
+      </p:sp>
+      <p:sp>
+        <p:nvSpPr>
+          <p:cNvPr id="8" name="Rounded Rectangle 7"/>
+          <p:cNvSpPr/>
+          <p:nvPr/>
+        </p:nvSpPr>
+        <p:spPr>
+          <a:xfrm>
+            <a:off x="6293815" y="1965960"/>
+            <a:ext cx="5166360" cy="2011680"/>
+          </a:xfrm>
+          <a:prstGeom prst="roundRect">
+            <a:avLst/>
+          </a:prstGeom>
+          <a:solidFill>
+            <a:srgbClr val="1E293B"/>
+          </a:solidFill>
+          <a:ln w="19050">
+            <a:solidFill>
+              <a:srgbClr val="A855F7"/>
+            </a:solidFill>
+          </a:ln>
+        </p:spPr>
+        <p:style>
+          <a:lnRef idx="1">
+            <a:schemeClr val="accent1"/>
+          </a:lnRef>
+          <a:fillRef idx="3">
+            <a:schemeClr val="accent1"/>
+          </a:fillRef>
+          <a:effectRef idx="2">
+            <a:schemeClr val="accent1"/>
+          </a:effectRef>
+          <a:fontRef idx="minor">
+            <a:schemeClr val="lt1"/>
+          </a:fontRef>
+        </p:style>
+        <p:txBody>
+          <a:bodyPr rtlCol="0" anchor="ctr"/>
+          <a:lstStyle/>
+          <a:p>
+            <a:pPr algn="ctr"/>
+          </a:p>
+        </p:txBody>
+      </p:sp>
+      <p:sp>
+        <p:nvSpPr>
+          <p:cNvPr id="9" name="TextBox 8"/>
+          <p:cNvSpPr txBox="1"/>
+          <p:nvPr/>
+        </p:nvSpPr>
+        <p:spPr>
+          <a:xfrm>
+            <a:off x="6568135" y="2286000"/>
+            <a:ext cx="4617720" cy="1371600"/>
+          </a:xfrm>
+          <a:prstGeom prst="rect">
+            <a:avLst/>
+          </a:prstGeom>
+          <a:noFill/>
+        </p:spPr>
+        <p:txBody>
+          <a:bodyPr wrap="square">
+            <a:spAutoFit/>
+          </a:bodyPr>
+          <a:lstStyle/>
+          <a:p>
+            <a:pPr>
+              <a:spcAft>
+                <a:spcPts val="1600"/>
+              </a:spcAft>
+              <a:defRPr sz="2400" b="1">
+                <a:solidFill>
+                  <a:srgbClr val="F8FAFC"/>
+                </a:solidFill>
+              </a:defRPr>
+            </a:pPr>
+            <a:r>
+              <a:t>Overcoming Overspecialization</a:t>
+            </a:r>
+          </a:p>
+          <a:p>
+            <a:pPr>
+              <a:spcAft>
+                <a:spcPts val="1200"/>
+              </a:spcAft>
+              <a:defRPr sz="1800">
+                <a:solidFill>
+                  <a:srgbClr val="E2E8F0"/>
+                </a:solidFill>
+              </a:defRPr>
+            </a:pPr>
+            <a:r>
+              <a:t>•  The Echo Chamber Problem: Pure Content-Based recommenders suffer from low diversity (0.1334), trapping users in one genre.</a:t>
+            </a:r>
+          </a:p>
+          <a:p>
+            <a:pPr>
+              <a:spcAft>
+                <a:spcPts val="1200"/>
+              </a:spcAft>
+              <a:defRPr sz="1800">
+                <a:solidFill>
+                  <a:srgbClr val="E2E8F0"/>
+                </a:solidFill>
+              </a:defRPr>
+            </a:pPr>
+            <a:r>
+              <a:t>•  Healthy Serendipity: Knowledge constraints (mood, length) pull candidates from neighboring genres that still fit the situation.</a:t>
+            </a:r>
+          </a:p>
+          <a:p>
+            <a:pPr>
+              <a:spcAft>
+                <a:spcPts val="1200"/>
+              </a:spcAft>
+              <a:defRPr sz="1800">
+                <a:solidFill>
+                  <a:srgbClr val="E2E8F0"/>
+                </a:solidFill>
+              </a:defRPr>
+            </a:pPr>
+            <a:r>
+              <a:t>•  +51% Diversity Improvement: The 1+1 Hybrid increases recommendation diversity from 0.1334 to 0.2017.</a:t>
+            </a:r>
+          </a:p>
+          <a:p>
+            <a:pPr>
+              <a:spcAft>
+                <a:spcPts val="1200"/>
+              </a:spcAft>
+              <a:defRPr sz="1800">
+                <a:solidFill>
+                  <a:srgbClr val="E2E8F0"/>
+                </a:solidFill>
+              </a:defRPr>
+            </a:pPr>
+            <a:r>
+              <a:t>•  Best of Both Worlds: Delivers fresh variety while preserving 100% relevance to the user's current needs.</a:t>
+            </a:r>
+          </a:p>
+        </p:txBody>
+      </p:sp>
+    </p:spTree>
+  </p:cSld>
+  <p:clrMapOvr>
+    <a:masterClrMapping/>
+  </p:clrMapOvr>
+</p:sld>
+</file>
+
+<file path=ppt/slides/slide14.xml><?xml version="1.0" encoding="utf-8"?>
 <p:sld xmlns:a="http://schemas.openxmlformats.org/drawingml/2006/main" xmlns:p="http://schemas.openxmlformats.org/presentationml/2006/main" xmlns:r="http://schemas.openxmlformats.org/officeDocument/2006/relationships">
   <p:cSld>
     <p:spTree>
@@ -5619,446 +6072,6 @@
 </p:sld>
 </file>
 
-<file path=ppt/slides/slide14.xml><?xml version="1.0" encoding="utf-8"?>
-<p:sld xmlns:a="http://schemas.openxmlformats.org/drawingml/2006/main" xmlns:p="http://schemas.openxmlformats.org/presentationml/2006/main" xmlns:r="http://schemas.openxmlformats.org/officeDocument/2006/relationships">
-  <p:cSld>
-    <p:spTree>
-      <p:nvGrpSpPr>
-        <p:cNvPr id="1" name=""/>
-        <p:cNvGrpSpPr/>
-        <p:nvPr/>
-      </p:nvGrpSpPr>
-      <p:grpSpPr/>
-      <p:sp>
-        <p:nvSpPr>
-          <p:cNvPr id="2" name="Rectangle 1"/>
-          <p:cNvSpPr/>
-          <p:nvPr/>
-        </p:nvSpPr>
-        <p:spPr>
-          <a:xfrm>
-            <a:off x="0" y="0"/>
-            <a:ext cx="12191695" cy="6858000"/>
-          </a:xfrm>
-          <a:prstGeom prst="rect">
-            <a:avLst/>
-          </a:prstGeom>
-          <a:solidFill>
-            <a:srgbClr val="0F172A"/>
-          </a:solidFill>
-          <a:ln>
-            <a:noFill/>
-          </a:ln>
-        </p:spPr>
-        <p:style>
-          <a:lnRef idx="1">
-            <a:schemeClr val="accent1"/>
-          </a:lnRef>
-          <a:fillRef idx="3">
-            <a:schemeClr val="accent1"/>
-          </a:fillRef>
-          <a:effectRef idx="2">
-            <a:schemeClr val="accent1"/>
-          </a:effectRef>
-          <a:fontRef idx="minor">
-            <a:schemeClr val="lt1"/>
-          </a:fontRef>
-        </p:style>
-        <p:txBody>
-          <a:bodyPr rtlCol="0" anchor="ctr"/>
-          <a:lstStyle/>
-          <a:p>
-            <a:pPr algn="ctr"/>
-          </a:p>
-        </p:txBody>
-      </p:sp>
-      <p:sp>
-        <p:nvSpPr>
-          <p:cNvPr id="3" name="TextBox 2"/>
-          <p:cNvSpPr txBox="1"/>
-          <p:nvPr/>
-        </p:nvSpPr>
-        <p:spPr>
-          <a:xfrm>
-            <a:off x="731520" y="320040"/>
-            <a:ext cx="10698480" cy="320040"/>
-          </a:xfrm>
-          <a:prstGeom prst="rect">
-            <a:avLst/>
-          </a:prstGeom>
-          <a:noFill/>
-        </p:spPr>
-        <p:txBody>
-          <a:bodyPr wrap="square" lIns="0" tIns="0" rIns="0" bIns="0">
-            <a:spAutoFit/>
-          </a:bodyPr>
-          <a:lstStyle/>
-          <a:p>
-            <a:pPr>
-              <a:defRPr sz="1800" b="1">
-                <a:solidFill>
-                  <a:srgbClr val="6366F1"/>
-                </a:solidFill>
-                <a:latin typeface="Arial"/>
-              </a:defRPr>
-            </a:pPr>
-            <a:r>
-              <a:t>USER EXPERIENCE &amp; UI</a:t>
-            </a:r>
-          </a:p>
-        </p:txBody>
-      </p:sp>
-      <p:sp>
-        <p:nvSpPr>
-          <p:cNvPr id="4" name="TextBox 3"/>
-          <p:cNvSpPr txBox="1"/>
-          <p:nvPr/>
-        </p:nvSpPr>
-        <p:spPr>
-          <a:xfrm>
-            <a:off x="731520" y="685800"/>
-            <a:ext cx="10698480" cy="594360"/>
-          </a:xfrm>
-          <a:prstGeom prst="rect">
-            <a:avLst/>
-          </a:prstGeom>
-          <a:noFill/>
-        </p:spPr>
-        <p:txBody>
-          <a:bodyPr wrap="square" lIns="0" tIns="0" rIns="0" bIns="0">
-            <a:spAutoFit/>
-          </a:bodyPr>
-          <a:lstStyle/>
-          <a:p>
-            <a:pPr>
-              <a:defRPr sz="3200" b="1">
-                <a:solidFill>
-                  <a:srgbClr val="F8FAFC"/>
-                </a:solidFill>
-                <a:latin typeface="Helvetica"/>
-              </a:defRPr>
-            </a:pPr>
-            <a:r>
-              <a:t>Modern Interactive Platform Interface</a:t>
-            </a:r>
-          </a:p>
-        </p:txBody>
-      </p:sp>
-      <p:sp>
-        <p:nvSpPr>
-          <p:cNvPr id="5" name="TextBox 4"/>
-          <p:cNvSpPr txBox="1"/>
-          <p:nvPr/>
-        </p:nvSpPr>
-        <p:spPr>
-          <a:xfrm>
-            <a:off x="731520" y="1298448"/>
-            <a:ext cx="10698480" cy="411480"/>
-          </a:xfrm>
-          <a:prstGeom prst="rect">
-            <a:avLst/>
-          </a:prstGeom>
-          <a:noFill/>
-        </p:spPr>
-        <p:txBody>
-          <a:bodyPr wrap="square" lIns="0" tIns="0" rIns="0" bIns="0">
-            <a:spAutoFit/>
-          </a:bodyPr>
-          <a:lstStyle/>
-          <a:p>
-            <a:pPr>
-              <a:defRPr sz="2000">
-                <a:solidFill>
-                  <a:srgbClr val="94A3B8"/>
-                </a:solidFill>
-                <a:latin typeface="Arial"/>
-              </a:defRPr>
-            </a:pPr>
-            <a:r>
-              <a:t>Designed with streaming-grade aesthetics for effortless decision making.</a:t>
-            </a:r>
-          </a:p>
-        </p:txBody>
-      </p:sp>
-      <p:sp>
-        <p:nvSpPr>
-          <p:cNvPr id="6" name="Rounded Rectangle 5"/>
-          <p:cNvSpPr/>
-          <p:nvPr/>
-        </p:nvSpPr>
-        <p:spPr>
-          <a:xfrm>
-            <a:off x="731520" y="1965960"/>
-            <a:ext cx="5166360" cy="2011680"/>
-          </a:xfrm>
-          <a:prstGeom prst="roundRect">
-            <a:avLst/>
-          </a:prstGeom>
-          <a:solidFill>
-            <a:srgbClr val="1E293B"/>
-          </a:solidFill>
-          <a:ln w="19050">
-            <a:solidFill>
-              <a:srgbClr val="6366F1"/>
-            </a:solidFill>
-          </a:ln>
-        </p:spPr>
-        <p:style>
-          <a:lnRef idx="1">
-            <a:schemeClr val="accent1"/>
-          </a:lnRef>
-          <a:fillRef idx="3">
-            <a:schemeClr val="accent1"/>
-          </a:fillRef>
-          <a:effectRef idx="2">
-            <a:schemeClr val="accent1"/>
-          </a:effectRef>
-          <a:fontRef idx="minor">
-            <a:schemeClr val="lt1"/>
-          </a:fontRef>
-        </p:style>
-        <p:txBody>
-          <a:bodyPr rtlCol="0" anchor="ctr"/>
-          <a:lstStyle/>
-          <a:p>
-            <a:pPr algn="ctr"/>
-          </a:p>
-        </p:txBody>
-      </p:sp>
-      <p:sp>
-        <p:nvSpPr>
-          <p:cNvPr id="7" name="TextBox 6"/>
-          <p:cNvSpPr txBox="1"/>
-          <p:nvPr/>
-        </p:nvSpPr>
-        <p:spPr>
-          <a:xfrm>
-            <a:off x="1005840" y="2286000"/>
-            <a:ext cx="4617720" cy="1371600"/>
-          </a:xfrm>
-          <a:prstGeom prst="rect">
-            <a:avLst/>
-          </a:prstGeom>
-          <a:noFill/>
-        </p:spPr>
-        <p:txBody>
-          <a:bodyPr wrap="square">
-            <a:spAutoFit/>
-          </a:bodyPr>
-          <a:lstStyle/>
-          <a:p>
-            <a:pPr>
-              <a:spcAft>
-                <a:spcPts val="1600"/>
-              </a:spcAft>
-              <a:defRPr sz="2400" b="1">
-                <a:solidFill>
-                  <a:srgbClr val="F8FAFC"/>
-                </a:solidFill>
-              </a:defRPr>
-            </a:pPr>
-            <a:r>
-              <a:t>Smart Match Decision Center</a:t>
-            </a:r>
-          </a:p>
-          <a:p>
-            <a:pPr>
-              <a:spcAft>
-                <a:spcPts val="1200"/>
-              </a:spcAft>
-              <a:defRPr sz="1800">
-                <a:solidFill>
-                  <a:srgbClr val="E2E8F0"/>
-                </a:solidFill>
-              </a:defRPr>
-            </a:pPr>
-            <a:r>
-              <a:t>•  Interactive Sliders: Real-time control of maximum episode budgets (≤ 13, ≤ 26, ≤ 50 eps) and minimum rating thresholds.</a:t>
-            </a:r>
-          </a:p>
-          <a:p>
-            <a:pPr>
-              <a:spcAft>
-                <a:spcPts val="1200"/>
-              </a:spcAft>
-              <a:defRPr sz="1800">
-                <a:solidFill>
-                  <a:srgbClr val="E2E8F0"/>
-                </a:solidFill>
-              </a:defRPr>
-            </a:pPr>
-            <a:r>
-              <a:t>•  Mood &amp; Genre Pills: One-click selection of viewing moods (Exciting, Chill, Dark, Emotional) and required/excluded genres.</a:t>
-            </a:r>
-          </a:p>
-          <a:p>
-            <a:pPr>
-              <a:spcAft>
-                <a:spcPts val="1200"/>
-              </a:spcAft>
-              <a:defRPr sz="1800">
-                <a:solidFill>
-                  <a:srgbClr val="E2E8F0"/>
-                </a:solidFill>
-              </a:defRPr>
-            </a:pPr>
-            <a:r>
-              <a:t>•  Instant Mathematical Scores: Displays both Taste Match % and Requirement Fit % alongside the combined Hybrid Score %.</a:t>
-            </a:r>
-          </a:p>
-        </p:txBody>
-      </p:sp>
-      <p:sp>
-        <p:nvSpPr>
-          <p:cNvPr id="8" name="Rounded Rectangle 7"/>
-          <p:cNvSpPr/>
-          <p:nvPr/>
-        </p:nvSpPr>
-        <p:spPr>
-          <a:xfrm>
-            <a:off x="6293815" y="1965960"/>
-            <a:ext cx="5166360" cy="2011680"/>
-          </a:xfrm>
-          <a:prstGeom prst="roundRect">
-            <a:avLst/>
-          </a:prstGeom>
-          <a:solidFill>
-            <a:srgbClr val="1E293B"/>
-          </a:solidFill>
-          <a:ln w="19050">
-            <a:solidFill>
-              <a:srgbClr val="F59E0B"/>
-            </a:solidFill>
-          </a:ln>
-        </p:spPr>
-        <p:style>
-          <a:lnRef idx="1">
-            <a:schemeClr val="accent1"/>
-          </a:lnRef>
-          <a:fillRef idx="3">
-            <a:schemeClr val="accent1"/>
-          </a:fillRef>
-          <a:effectRef idx="2">
-            <a:schemeClr val="accent1"/>
-          </a:effectRef>
-          <a:fontRef idx="minor">
-            <a:schemeClr val="lt1"/>
-          </a:fontRef>
-        </p:style>
-        <p:txBody>
-          <a:bodyPr rtlCol="0" anchor="ctr"/>
-          <a:lstStyle/>
-          <a:p>
-            <a:pPr algn="ctr"/>
-          </a:p>
-        </p:txBody>
-      </p:sp>
-      <p:sp>
-        <p:nvSpPr>
-          <p:cNvPr id="9" name="TextBox 8"/>
-          <p:cNvSpPr txBox="1"/>
-          <p:nvPr/>
-        </p:nvSpPr>
-        <p:spPr>
-          <a:xfrm>
-            <a:off x="6568135" y="2286000"/>
-            <a:ext cx="4617720" cy="1371600"/>
-          </a:xfrm>
-          <a:prstGeom prst="rect">
-            <a:avLst/>
-          </a:prstGeom>
-          <a:noFill/>
-        </p:spPr>
-        <p:txBody>
-          <a:bodyPr wrap="square">
-            <a:spAutoFit/>
-          </a:bodyPr>
-          <a:lstStyle/>
-          <a:p>
-            <a:pPr>
-              <a:spcAft>
-                <a:spcPts val="1600"/>
-              </a:spcAft>
-              <a:defRPr sz="2400" b="1">
-                <a:solidFill>
-                  <a:srgbClr val="F8FAFC"/>
-                </a:solidFill>
-              </a:defRPr>
-            </a:pPr>
-            <a:r>
-              <a:t>Detail View &amp; Discovery</a:t>
-            </a:r>
-          </a:p>
-          <a:p>
-            <a:pPr>
-              <a:spcAft>
-                <a:spcPts val="1000"/>
-              </a:spcAft>
-              <a:defRPr sz="1800">
-                <a:solidFill>
-                  <a:srgbClr val="E2E8F0"/>
-                </a:solidFill>
-              </a:defRPr>
-            </a:pPr>
-            <a:r>
-              <a:t>•  Rating Distribution Histogram: Interactive 1-to-5 star vote breakdown bars located directly inside the anime hero container.</a:t>
-            </a:r>
-          </a:p>
-          <a:p>
-            <a:pPr>
-              <a:spcAft>
-                <a:spcPts val="1000"/>
-              </a:spcAft>
-              <a:defRPr sz="1800">
-                <a:solidFill>
-                  <a:srgbClr val="E2E8F0"/>
-                </a:solidFill>
-              </a:defRPr>
-            </a:pPr>
-            <a:r>
-              <a:t>•  Netflix-Style Carousels: Reusable horizontal carousel rows for 'More Like This' and 'Recommended For You' with chevron navigation.</a:t>
-            </a:r>
-          </a:p>
-          <a:p>
-            <a:pPr>
-              <a:spcAft>
-                <a:spcPts val="1000"/>
-              </a:spcAft>
-              <a:defRPr sz="1800">
-                <a:solidFill>
-                  <a:srgbClr val="E2E8F0"/>
-                </a:solidFill>
-              </a:defRPr>
-            </a:pPr>
-            <a:r>
-              <a:t>•  3D Responsive Canvas: Dynamic background particle grid responding to mouse movements across all pages.</a:t>
-            </a:r>
-          </a:p>
-          <a:p>
-            <a:pPr>
-              <a:spcAft>
-                <a:spcPts val="1000"/>
-              </a:spcAft>
-              <a:defRPr sz="1800">
-                <a:solidFill>
-                  <a:srgbClr val="E2E8F0"/>
-                </a:solidFill>
-              </a:defRPr>
-            </a:pPr>
-            <a:r>
-              <a:t>•  Dark &amp; Light Mode: Full theme toggle support with accessible color contrast.</a:t>
-            </a:r>
-          </a:p>
-        </p:txBody>
-      </p:sp>
-    </p:spTree>
-  </p:cSld>
-  <p:clrMapOvr>
-    <a:masterClrMapping/>
-  </p:clrMapOvr>
-</p:sld>
-</file>
-
 <file path=ppt/slides/slide15.xml><?xml version="1.0" encoding="utf-8"?>
 <p:sld xmlns:a="http://schemas.openxmlformats.org/drawingml/2006/main" xmlns:p="http://schemas.openxmlformats.org/presentationml/2006/main" xmlns:r="http://schemas.openxmlformats.org/officeDocument/2006/relationships">
   <p:cSld>
@@ -6143,7 +6156,7 @@
               </a:defRPr>
             </a:pPr>
             <a:r>
-              <a:t>ENGINEERING &amp; DEPLOYMENT</a:t>
+              <a:t>USER EXPERIENCE &amp; UI</a:t>
             </a:r>
           </a:p>
         </p:txBody>
@@ -6179,7 +6192,7 @@
               </a:defRPr>
             </a:pPr>
             <a:r>
-              <a:t>100% Free Cloud Architecture</a:t>
+              <a:t>Modern Interactive Platform Interface</a:t>
             </a:r>
           </a:p>
         </p:txBody>
@@ -6215,7 +6228,7 @@
               </a:defRPr>
             </a:pPr>
             <a:r>
-              <a:t>Publicly accessible worldwide with zero server hosting costs.</a:t>
+              <a:t>Designed with streaming-grade aesthetics for effortless decision making.</a:t>
             </a:r>
           </a:p>
         </p:txBody>
@@ -6298,7 +6311,7 @@
               </a:defRPr>
             </a:pPr>
             <a:r>
-              <a:t>Hugging Face Spaces (Live App)</a:t>
+              <a:t>Smart Match Decision Center</a:t>
             </a:r>
           </a:p>
           <a:p>
@@ -6313,11 +6326,7 @@
               </a:defRPr>
             </a:pPr>
             <a:r>
-              <a:t>•  Live Public URL:</a:t>
-            </a:r>
-            <a:br/>
-            <a:r>
-              <a:t>  https://minkhanttin-anivibe.static.hf.space</a:t>
+              <a:t>•  Interactive Sliders: Real-time control of maximum episode budgets (≤ 13, ≤ 26, ≤ 50 eps) and minimum rating thresholds.</a:t>
             </a:r>
           </a:p>
           <a:p>
@@ -6332,7 +6341,7 @@
               </a:defRPr>
             </a:pPr>
             <a:r>
-              <a:t>•  100% Free Static Hosting: Deployed using Hugging Face Static SDK, requiring $0.00/month and no paid Docker instance.</a:t>
+              <a:t>•  Mood &amp; Genre Pills: One-click selection of viewing moods (Exciting, Chill, Dark, Emotional) and required/excluded genres.</a:t>
             </a:r>
           </a:p>
           <a:p>
@@ -6347,22 +6356,7 @@
               </a:defRPr>
             </a:pPr>
             <a:r>
-              <a:t>•  Zero Downtime &amp; Global CDN: Accessible worldwide with instant load times on phones, iPads, and PCs.</a:t>
-            </a:r>
-          </a:p>
-          <a:p>
-            <a:pPr>
-              <a:spcAft>
-                <a:spcPts val="1200"/>
-              </a:spcAft>
-              <a:defRPr sz="1800">
-                <a:solidFill>
-                  <a:srgbClr val="E2E8F0"/>
-                </a:solidFill>
-              </a:defRPr>
-            </a:pPr>
-            <a:r>
-              <a:t>•  Client-Side Academic Engine: Computes all 4 recommendation algorithms in JavaScript in &lt; 3 ms directly in the browser.</a:t>
+              <a:t>•  Instant Mathematical Scores: Displays both Taste Match % and Requirement Fit % alongside the combined Hybrid Score %.</a:t>
             </a:r>
           </a:p>
         </p:txBody>
@@ -6386,7 +6380,7 @@
           </a:solidFill>
           <a:ln w="19050">
             <a:solidFill>
-              <a:srgbClr val="A855F7"/>
+              <a:srgbClr val="F59E0B"/>
             </a:solidFill>
           </a:ln>
         </p:spPr>
@@ -6445,13 +6439,13 @@
               </a:defRPr>
             </a:pPr>
             <a:r>
-              <a:t>GitHub Open-Source Codebase</a:t>
-            </a:r>
-          </a:p>
-          <a:p>
-            <a:pPr>
-              <a:spcAft>
-                <a:spcPts val="1200"/>
+              <a:t>Detail View &amp; Discovery</a:t>
+            </a:r>
+          </a:p>
+          <a:p>
+            <a:pPr>
+              <a:spcAft>
+                <a:spcPts val="1000"/>
               </a:spcAft>
               <a:defRPr sz="1800">
                 <a:solidFill>
@@ -6460,17 +6454,13 @@
               </a:defRPr>
             </a:pPr>
             <a:r>
-              <a:t>•  Official Repository:</a:t>
-            </a:r>
-            <a:br/>
-            <a:r>
-              <a:t>  https://github.com/manisandar/anime-dsrs</a:t>
-            </a:r>
-          </a:p>
-          <a:p>
-            <a:pPr>
-              <a:spcAft>
-                <a:spcPts val="1200"/>
+              <a:t>•  Rating Distribution Histogram: Interactive 1-to-5 star vote breakdown bars located directly inside the anime hero container.</a:t>
+            </a:r>
+          </a:p>
+          <a:p>
+            <a:pPr>
+              <a:spcAft>
+                <a:spcPts val="1000"/>
               </a:spcAft>
               <a:defRPr sz="1800">
                 <a:solidFill>
@@ -6479,13 +6469,13 @@
               </a:defRPr>
             </a:pPr>
             <a:r>
-              <a:t>•  Core Python Algorithms: Complete implementations in recommender/algorithms.py and pipeline.py.</a:t>
-            </a:r>
-          </a:p>
-          <a:p>
-            <a:pPr>
-              <a:spcAft>
-                <a:spcPts val="1200"/>
+              <a:t>•  Netflix-Style Carousels: Reusable horizontal carousel rows for 'More Like This' and 'Recommended For You' with chevron navigation.</a:t>
+            </a:r>
+          </a:p>
+          <a:p>
+            <a:pPr>
+              <a:spcAft>
+                <a:spcPts val="1000"/>
               </a:spcAft>
               <a:defRPr sz="1800">
                 <a:solidFill>
@@ -6494,13 +6484,13 @@
               </a:defRPr>
             </a:pPr>
             <a:r>
-              <a:t>•  Reproducible Benchmarks: Anyone can run 'python3 recommender/evaluate.py' to verify the benchmark metrics.</a:t>
-            </a:r>
-          </a:p>
-          <a:p>
-            <a:pPr>
-              <a:spcAft>
-                <a:spcPts val="1200"/>
+              <a:t>•  3D Responsive Canvas: Dynamic background particle grid responding to mouse movements across all pages.</a:t>
+            </a:r>
+          </a:p>
+          <a:p>
+            <a:pPr>
+              <a:spcAft>
+                <a:spcPts val="1000"/>
               </a:spcAft>
               <a:defRPr sz="1800">
                 <a:solidFill>
@@ -6509,7 +6499,7 @@
               </a:defRPr>
             </a:pPr>
             <a:r>
-              <a:t>•  Clean Academic Formatting: Well-documented codebase ready for university examination and code inspection.</a:t>
+              <a:t>•  Dark &amp; Light Mode: Full theme toggle support with accessible color contrast.</a:t>
             </a:r>
           </a:p>
         </p:txBody>
@@ -6577,6 +6567,469 @@
       </p:sp>
       <p:sp>
         <p:nvSpPr>
+          <p:cNvPr id="3" name="TextBox 2"/>
+          <p:cNvSpPr txBox="1"/>
+          <p:nvPr/>
+        </p:nvSpPr>
+        <p:spPr>
+          <a:xfrm>
+            <a:off x="731520" y="320040"/>
+            <a:ext cx="10698480" cy="320040"/>
+          </a:xfrm>
+          <a:prstGeom prst="rect">
+            <a:avLst/>
+          </a:prstGeom>
+          <a:noFill/>
+        </p:spPr>
+        <p:txBody>
+          <a:bodyPr wrap="square" lIns="0" tIns="0" rIns="0" bIns="0">
+            <a:spAutoFit/>
+          </a:bodyPr>
+          <a:lstStyle/>
+          <a:p>
+            <a:pPr>
+              <a:defRPr sz="1800" b="1">
+                <a:solidFill>
+                  <a:srgbClr val="6366F1"/>
+                </a:solidFill>
+                <a:latin typeface="Arial"/>
+              </a:defRPr>
+            </a:pPr>
+            <a:r>
+              <a:t>ENGINEERING &amp; DEPLOYMENT</a:t>
+            </a:r>
+          </a:p>
+        </p:txBody>
+      </p:sp>
+      <p:sp>
+        <p:nvSpPr>
+          <p:cNvPr id="4" name="TextBox 3"/>
+          <p:cNvSpPr txBox="1"/>
+          <p:nvPr/>
+        </p:nvSpPr>
+        <p:spPr>
+          <a:xfrm>
+            <a:off x="731520" y="685800"/>
+            <a:ext cx="10698480" cy="594360"/>
+          </a:xfrm>
+          <a:prstGeom prst="rect">
+            <a:avLst/>
+          </a:prstGeom>
+          <a:noFill/>
+        </p:spPr>
+        <p:txBody>
+          <a:bodyPr wrap="square" lIns="0" tIns="0" rIns="0" bIns="0">
+            <a:spAutoFit/>
+          </a:bodyPr>
+          <a:lstStyle/>
+          <a:p>
+            <a:pPr>
+              <a:defRPr sz="3200" b="1">
+                <a:solidFill>
+                  <a:srgbClr val="F8FAFC"/>
+                </a:solidFill>
+                <a:latin typeface="Helvetica"/>
+              </a:defRPr>
+            </a:pPr>
+            <a:r>
+              <a:t>100% Free Cloud Architecture</a:t>
+            </a:r>
+          </a:p>
+        </p:txBody>
+      </p:sp>
+      <p:sp>
+        <p:nvSpPr>
+          <p:cNvPr id="5" name="TextBox 4"/>
+          <p:cNvSpPr txBox="1"/>
+          <p:nvPr/>
+        </p:nvSpPr>
+        <p:spPr>
+          <a:xfrm>
+            <a:off x="731520" y="1298448"/>
+            <a:ext cx="10698480" cy="411480"/>
+          </a:xfrm>
+          <a:prstGeom prst="rect">
+            <a:avLst/>
+          </a:prstGeom>
+          <a:noFill/>
+        </p:spPr>
+        <p:txBody>
+          <a:bodyPr wrap="square" lIns="0" tIns="0" rIns="0" bIns="0">
+            <a:spAutoFit/>
+          </a:bodyPr>
+          <a:lstStyle/>
+          <a:p>
+            <a:pPr>
+              <a:defRPr sz="2000">
+                <a:solidFill>
+                  <a:srgbClr val="94A3B8"/>
+                </a:solidFill>
+                <a:latin typeface="Arial"/>
+              </a:defRPr>
+            </a:pPr>
+            <a:r>
+              <a:t>Publicly accessible worldwide with zero server hosting costs.</a:t>
+            </a:r>
+          </a:p>
+        </p:txBody>
+      </p:sp>
+      <p:sp>
+        <p:nvSpPr>
+          <p:cNvPr id="6" name="Rounded Rectangle 5"/>
+          <p:cNvSpPr/>
+          <p:nvPr/>
+        </p:nvSpPr>
+        <p:spPr>
+          <a:xfrm>
+            <a:off x="731520" y="1965960"/>
+            <a:ext cx="5166360" cy="2011680"/>
+          </a:xfrm>
+          <a:prstGeom prst="roundRect">
+            <a:avLst/>
+          </a:prstGeom>
+          <a:solidFill>
+            <a:srgbClr val="1E293B"/>
+          </a:solidFill>
+          <a:ln w="19050">
+            <a:solidFill>
+              <a:srgbClr val="6366F1"/>
+            </a:solidFill>
+          </a:ln>
+        </p:spPr>
+        <p:style>
+          <a:lnRef idx="1">
+            <a:schemeClr val="accent1"/>
+          </a:lnRef>
+          <a:fillRef idx="3">
+            <a:schemeClr val="accent1"/>
+          </a:fillRef>
+          <a:effectRef idx="2">
+            <a:schemeClr val="accent1"/>
+          </a:effectRef>
+          <a:fontRef idx="minor">
+            <a:schemeClr val="lt1"/>
+          </a:fontRef>
+        </p:style>
+        <p:txBody>
+          <a:bodyPr rtlCol="0" anchor="ctr"/>
+          <a:lstStyle/>
+          <a:p>
+            <a:pPr algn="ctr"/>
+          </a:p>
+        </p:txBody>
+      </p:sp>
+      <p:sp>
+        <p:nvSpPr>
+          <p:cNvPr id="7" name="TextBox 6"/>
+          <p:cNvSpPr txBox="1"/>
+          <p:nvPr/>
+        </p:nvSpPr>
+        <p:spPr>
+          <a:xfrm>
+            <a:off x="1005840" y="2286000"/>
+            <a:ext cx="4617720" cy="1371600"/>
+          </a:xfrm>
+          <a:prstGeom prst="rect">
+            <a:avLst/>
+          </a:prstGeom>
+          <a:noFill/>
+        </p:spPr>
+        <p:txBody>
+          <a:bodyPr wrap="square">
+            <a:spAutoFit/>
+          </a:bodyPr>
+          <a:lstStyle/>
+          <a:p>
+            <a:pPr>
+              <a:spcAft>
+                <a:spcPts val="1600"/>
+              </a:spcAft>
+              <a:defRPr sz="2400" b="1">
+                <a:solidFill>
+                  <a:srgbClr val="F8FAFC"/>
+                </a:solidFill>
+              </a:defRPr>
+            </a:pPr>
+            <a:r>
+              <a:t>Hugging Face Spaces (Live App)</a:t>
+            </a:r>
+          </a:p>
+          <a:p>
+            <a:pPr>
+              <a:spcAft>
+                <a:spcPts val="1200"/>
+              </a:spcAft>
+              <a:defRPr sz="1800">
+                <a:solidFill>
+                  <a:srgbClr val="E2E8F0"/>
+                </a:solidFill>
+              </a:defRPr>
+            </a:pPr>
+            <a:r>
+              <a:t>•  Live Public URL:</a:t>
+            </a:r>
+            <a:br/>
+            <a:r>
+              <a:t>  https://minkhanttin-anivibe.static.hf.space</a:t>
+            </a:r>
+          </a:p>
+          <a:p>
+            <a:pPr>
+              <a:spcAft>
+                <a:spcPts val="1200"/>
+              </a:spcAft>
+              <a:defRPr sz="1800">
+                <a:solidFill>
+                  <a:srgbClr val="E2E8F0"/>
+                </a:solidFill>
+              </a:defRPr>
+            </a:pPr>
+            <a:r>
+              <a:t>•  100% Free Static Hosting: Deployed using Hugging Face Static SDK, requiring $0.00/month and no paid Docker instance.</a:t>
+            </a:r>
+          </a:p>
+          <a:p>
+            <a:pPr>
+              <a:spcAft>
+                <a:spcPts val="1200"/>
+              </a:spcAft>
+              <a:defRPr sz="1800">
+                <a:solidFill>
+                  <a:srgbClr val="E2E8F0"/>
+                </a:solidFill>
+              </a:defRPr>
+            </a:pPr>
+            <a:r>
+              <a:t>•  Zero Downtime &amp; Global CDN: Accessible worldwide with instant load times on phones, iPads, and PCs.</a:t>
+            </a:r>
+          </a:p>
+          <a:p>
+            <a:pPr>
+              <a:spcAft>
+                <a:spcPts val="1200"/>
+              </a:spcAft>
+              <a:defRPr sz="1800">
+                <a:solidFill>
+                  <a:srgbClr val="E2E8F0"/>
+                </a:solidFill>
+              </a:defRPr>
+            </a:pPr>
+            <a:r>
+              <a:t>•  Client-Side Academic Engine: Computes all 4 recommendation algorithms in JavaScript in &lt; 3 ms directly in the browser.</a:t>
+            </a:r>
+          </a:p>
+        </p:txBody>
+      </p:sp>
+      <p:sp>
+        <p:nvSpPr>
+          <p:cNvPr id="8" name="Rounded Rectangle 7"/>
+          <p:cNvSpPr/>
+          <p:nvPr/>
+        </p:nvSpPr>
+        <p:spPr>
+          <a:xfrm>
+            <a:off x="6293815" y="1965960"/>
+            <a:ext cx="5166360" cy="2011680"/>
+          </a:xfrm>
+          <a:prstGeom prst="roundRect">
+            <a:avLst/>
+          </a:prstGeom>
+          <a:solidFill>
+            <a:srgbClr val="1E293B"/>
+          </a:solidFill>
+          <a:ln w="19050">
+            <a:solidFill>
+              <a:srgbClr val="A855F7"/>
+            </a:solidFill>
+          </a:ln>
+        </p:spPr>
+        <p:style>
+          <a:lnRef idx="1">
+            <a:schemeClr val="accent1"/>
+          </a:lnRef>
+          <a:fillRef idx="3">
+            <a:schemeClr val="accent1"/>
+          </a:fillRef>
+          <a:effectRef idx="2">
+            <a:schemeClr val="accent1"/>
+          </a:effectRef>
+          <a:fontRef idx="minor">
+            <a:schemeClr val="lt1"/>
+          </a:fontRef>
+        </p:style>
+        <p:txBody>
+          <a:bodyPr rtlCol="0" anchor="ctr"/>
+          <a:lstStyle/>
+          <a:p>
+            <a:pPr algn="ctr"/>
+          </a:p>
+        </p:txBody>
+      </p:sp>
+      <p:sp>
+        <p:nvSpPr>
+          <p:cNvPr id="9" name="TextBox 8"/>
+          <p:cNvSpPr txBox="1"/>
+          <p:nvPr/>
+        </p:nvSpPr>
+        <p:spPr>
+          <a:xfrm>
+            <a:off x="6568135" y="2286000"/>
+            <a:ext cx="4617720" cy="1371600"/>
+          </a:xfrm>
+          <a:prstGeom prst="rect">
+            <a:avLst/>
+          </a:prstGeom>
+          <a:noFill/>
+        </p:spPr>
+        <p:txBody>
+          <a:bodyPr wrap="square">
+            <a:spAutoFit/>
+          </a:bodyPr>
+          <a:lstStyle/>
+          <a:p>
+            <a:pPr>
+              <a:spcAft>
+                <a:spcPts val="1600"/>
+              </a:spcAft>
+              <a:defRPr sz="2400" b="1">
+                <a:solidFill>
+                  <a:srgbClr val="F8FAFC"/>
+                </a:solidFill>
+              </a:defRPr>
+            </a:pPr>
+            <a:r>
+              <a:t>GitHub Open-Source Codebase</a:t>
+            </a:r>
+          </a:p>
+          <a:p>
+            <a:pPr>
+              <a:spcAft>
+                <a:spcPts val="1200"/>
+              </a:spcAft>
+              <a:defRPr sz="1800">
+                <a:solidFill>
+                  <a:srgbClr val="E2E8F0"/>
+                </a:solidFill>
+              </a:defRPr>
+            </a:pPr>
+            <a:r>
+              <a:t>•  Official Repository:</a:t>
+            </a:r>
+            <a:br/>
+            <a:r>
+              <a:t>  https://github.com/manisandar/anime-dsrs</a:t>
+            </a:r>
+          </a:p>
+          <a:p>
+            <a:pPr>
+              <a:spcAft>
+                <a:spcPts val="1200"/>
+              </a:spcAft>
+              <a:defRPr sz="1800">
+                <a:solidFill>
+                  <a:srgbClr val="E2E8F0"/>
+                </a:solidFill>
+              </a:defRPr>
+            </a:pPr>
+            <a:r>
+              <a:t>•  Core Python Algorithms: Complete implementations in recommender/algorithms.py and pipeline.py.</a:t>
+            </a:r>
+          </a:p>
+          <a:p>
+            <a:pPr>
+              <a:spcAft>
+                <a:spcPts val="1200"/>
+              </a:spcAft>
+              <a:defRPr sz="1800">
+                <a:solidFill>
+                  <a:srgbClr val="E2E8F0"/>
+                </a:solidFill>
+              </a:defRPr>
+            </a:pPr>
+            <a:r>
+              <a:t>•  Reproducible Benchmarks: Anyone can run 'python3 recommender/evaluate.py' to verify the benchmark metrics.</a:t>
+            </a:r>
+          </a:p>
+          <a:p>
+            <a:pPr>
+              <a:spcAft>
+                <a:spcPts val="1200"/>
+              </a:spcAft>
+              <a:defRPr sz="1800">
+                <a:solidFill>
+                  <a:srgbClr val="E2E8F0"/>
+                </a:solidFill>
+              </a:defRPr>
+            </a:pPr>
+            <a:r>
+              <a:t>•  Clean Academic Formatting: Well-documented codebase ready for university examination and code inspection.</a:t>
+            </a:r>
+          </a:p>
+        </p:txBody>
+      </p:sp>
+    </p:spTree>
+  </p:cSld>
+  <p:clrMapOvr>
+    <a:masterClrMapping/>
+  </p:clrMapOvr>
+</p:sld>
+</file>
+
+<file path=ppt/slides/slide17.xml><?xml version="1.0" encoding="utf-8"?>
+<p:sld xmlns:a="http://schemas.openxmlformats.org/drawingml/2006/main" xmlns:p="http://schemas.openxmlformats.org/presentationml/2006/main" xmlns:r="http://schemas.openxmlformats.org/officeDocument/2006/relationships">
+  <p:cSld>
+    <p:spTree>
+      <p:nvGrpSpPr>
+        <p:cNvPr id="1" name=""/>
+        <p:cNvGrpSpPr/>
+        <p:nvPr/>
+      </p:nvGrpSpPr>
+      <p:grpSpPr/>
+      <p:sp>
+        <p:nvSpPr>
+          <p:cNvPr id="2" name="Rectangle 1"/>
+          <p:cNvSpPr/>
+          <p:nvPr/>
+        </p:nvSpPr>
+        <p:spPr>
+          <a:xfrm>
+            <a:off x="0" y="0"/>
+            <a:ext cx="12191695" cy="6858000"/>
+          </a:xfrm>
+          <a:prstGeom prst="rect">
+            <a:avLst/>
+          </a:prstGeom>
+          <a:solidFill>
+            <a:srgbClr val="0F172A"/>
+          </a:solidFill>
+          <a:ln>
+            <a:noFill/>
+          </a:ln>
+        </p:spPr>
+        <p:style>
+          <a:lnRef idx="1">
+            <a:schemeClr val="accent1"/>
+          </a:lnRef>
+          <a:fillRef idx="3">
+            <a:schemeClr val="accent1"/>
+          </a:fillRef>
+          <a:effectRef idx="2">
+            <a:schemeClr val="accent1"/>
+          </a:effectRef>
+          <a:fontRef idx="minor">
+            <a:schemeClr val="lt1"/>
+          </a:fontRef>
+        </p:style>
+        <p:txBody>
+          <a:bodyPr rtlCol="0" anchor="ctr"/>
+          <a:lstStyle/>
+          <a:p>
+            <a:pPr algn="ctr"/>
+          </a:p>
+        </p:txBody>
+      </p:sp>
+      <p:sp>
+        <p:nvSpPr>
           <p:cNvPr id="3" name="Rounded Rectangle 2"/>
           <p:cNvSpPr/>
           <p:nvPr/>
@@ -6838,7 +7291,7 @@
               </a:defRPr>
             </a:pPr>
             <a:r>
-              <a:t>PROBLEM STATEMENT &amp; MOTIVATION</a:t>
+              <a:t>PROJECT OVERVIEW &amp; FOUNDATIONS</a:t>
             </a:r>
           </a:p>
         </p:txBody>
@@ -6874,7 +7327,7 @@
               </a:defRPr>
             </a:pPr>
             <a:r>
-              <a:t>The 'Paradox of Choice' in Streaming</a:t>
+              <a:t>Title 1 — Introduction</a:t>
             </a:r>
           </a:p>
         </p:txBody>
@@ -6910,7 +7363,7 @@
               </a:defRPr>
             </a:pPr>
             <a:r>
-              <a:t>Why viewers struggle to pick an anime, and why typical recommenders fail.</a:t>
+              <a:t>ANIVIBE: Decision Support &amp; Pure Content-Based Anime Recommender System</a:t>
             </a:r>
           </a:p>
         </p:txBody>
@@ -6918,6 +7371,292 @@
       <p:sp>
         <p:nvSpPr>
           <p:cNvPr id="6" name="Rounded Rectangle 5"/>
+          <p:cNvSpPr/>
+          <p:nvPr/>
+        </p:nvSpPr>
+        <p:spPr>
+          <a:xfrm>
+            <a:off x="731520" y="1965960"/>
+            <a:ext cx="5166360" cy="4297680"/>
+          </a:xfrm>
+          <a:prstGeom prst="roundRect">
+            <a:avLst/>
+          </a:prstGeom>
+          <a:solidFill>
+            <a:srgbClr val="1E293B"/>
+          </a:solidFill>
+          <a:ln w="19050">
+            <a:solidFill>
+              <a:srgbClr val="6366F1"/>
+            </a:solidFill>
+          </a:ln>
+        </p:spPr>
+        <p:style>
+          <a:lnRef idx="1">
+            <a:schemeClr val="accent1"/>
+          </a:lnRef>
+          <a:fillRef idx="3">
+            <a:schemeClr val="accent1"/>
+          </a:fillRef>
+          <a:effectRef idx="2">
+            <a:schemeClr val="accent1"/>
+          </a:effectRef>
+          <a:fontRef idx="minor">
+            <a:schemeClr val="lt1"/>
+          </a:fontRef>
+        </p:style>
+        <p:txBody>
+          <a:bodyPr rtlCol="0" anchor="ctr"/>
+          <a:lstStyle/>
+          <a:p>
+            <a:pPr algn="ctr"/>
+          </a:p>
+        </p:txBody>
+      </p:sp>
+      <p:sp>
+        <p:nvSpPr>
+          <p:cNvPr id="7" name="TextBox 6"/>
+          <p:cNvSpPr txBox="1"/>
+          <p:nvPr/>
+        </p:nvSpPr>
+        <p:spPr>
+          <a:xfrm>
+            <a:off x="1005840" y="2286000"/>
+            <a:ext cx="4617720" cy="3657600"/>
+          </a:xfrm>
+          <a:prstGeom prst="rect">
+            <a:avLst/>
+          </a:prstGeom>
+          <a:noFill/>
+        </p:spPr>
+        <p:txBody>
+          <a:bodyPr wrap="square">
+            <a:spAutoFit/>
+          </a:bodyPr>
+          <a:lstStyle/>
+          <a:p>
+            <a:pPr>
+              <a:spcAft>
+                <a:spcPts val="1600"/>
+              </a:spcAft>
+              <a:defRPr sz="2400" b="1">
+                <a:solidFill>
+                  <a:srgbClr val="F8FAFC"/>
+                </a:solidFill>
+              </a:defRPr>
+            </a:pPr>
+            <a:r>
+              <a:t>Motivation &amp; Problem Scope</a:t>
+            </a:r>
+          </a:p>
+          <a:p>
+            <a:pPr>
+              <a:spcAft>
+                <a:spcPts val="1200"/>
+              </a:spcAft>
+              <a:defRPr sz="1800">
+                <a:solidFill>
+                  <a:srgbClr val="E2E8F0"/>
+                </a:solidFill>
+              </a:defRPr>
+            </a:pPr>
+            <a:r>
+              <a:t>•  The Choice Paradox: Streaming catalogs with 1,200+ titles cause decision paralysis; users spend 20–30 minutes browsing without watching.</a:t>
+            </a:r>
+          </a:p>
+          <a:p>
+            <a:pPr>
+              <a:spcAft>
+                <a:spcPts val="1200"/>
+              </a:spcAft>
+              <a:defRPr sz="1800">
+                <a:solidFill>
+                  <a:srgbClr val="E2E8F0"/>
+                </a:solidFill>
+              </a:defRPr>
+            </a:pPr>
+            <a:r>
+              <a:t>•  Black-Box Mystery: Typical platforms push generic blockbusters without explaining why titles were selected.</a:t>
+            </a:r>
+          </a:p>
+          <a:p>
+            <a:pPr>
+              <a:spcAft>
+                <a:spcPts val="1200"/>
+              </a:spcAft>
+              <a:defRPr sz="1800">
+                <a:solidFill>
+                  <a:srgbClr val="E2E8F0"/>
+                </a:solidFill>
+              </a:defRPr>
+            </a:pPr>
+            <a:r>
+              <a:t>•  Context Blind Spot: Traditional recommenders overlook current time constraints (episodes) and viewing moods.</a:t>
+            </a:r>
+          </a:p>
+          <a:p>
+            <a:pPr>
+              <a:spcAft>
+                <a:spcPts val="1200"/>
+              </a:spcAft>
+              <a:defRPr sz="1800">
+                <a:solidFill>
+                  <a:srgbClr val="E2E8F0"/>
+                </a:solidFill>
+              </a:defRPr>
+            </a:pPr>
+            <a:r>
+              <a:t>•  Academic Objective: Build an explainable, responsive recommender grounded in rigorous decision science for Assumption University.</a:t>
+            </a:r>
+          </a:p>
+        </p:txBody>
+      </p:sp>
+      <p:sp>
+        <p:nvSpPr>
+          <p:cNvPr id="8" name="Rounded Rectangle 7"/>
+          <p:cNvSpPr/>
+          <p:nvPr/>
+        </p:nvSpPr>
+        <p:spPr>
+          <a:xfrm>
+            <a:off x="6293815" y="1965960"/>
+            <a:ext cx="5166360" cy="4297680"/>
+          </a:xfrm>
+          <a:prstGeom prst="roundRect">
+            <a:avLst/>
+          </a:prstGeom>
+          <a:solidFill>
+            <a:srgbClr val="1E293B"/>
+          </a:solidFill>
+          <a:ln w="19050">
+            <a:solidFill>
+              <a:srgbClr val="06B6D4"/>
+            </a:solidFill>
+          </a:ln>
+        </p:spPr>
+        <p:style>
+          <a:lnRef idx="1">
+            <a:schemeClr val="accent1"/>
+          </a:lnRef>
+          <a:fillRef idx="3">
+            <a:schemeClr val="accent1"/>
+          </a:fillRef>
+          <a:effectRef idx="2">
+            <a:schemeClr val="accent1"/>
+          </a:effectRef>
+          <a:fontRef idx="minor">
+            <a:schemeClr val="lt1"/>
+          </a:fontRef>
+        </p:style>
+        <p:txBody>
+          <a:bodyPr rtlCol="0" anchor="ctr"/>
+          <a:lstStyle/>
+          <a:p>
+            <a:pPr algn="ctr"/>
+          </a:p>
+        </p:txBody>
+      </p:sp>
+      <p:sp>
+        <p:nvSpPr>
+          <p:cNvPr id="9" name="TextBox 8"/>
+          <p:cNvSpPr txBox="1"/>
+          <p:nvPr/>
+        </p:nvSpPr>
+        <p:spPr>
+          <a:xfrm>
+            <a:off x="6568135" y="2286000"/>
+            <a:ext cx="4617720" cy="3657600"/>
+          </a:xfrm>
+          <a:prstGeom prst="rect">
+            <a:avLst/>
+          </a:prstGeom>
+          <a:noFill/>
+        </p:spPr>
+        <p:txBody>
+          <a:bodyPr wrap="square">
+            <a:spAutoFit/>
+          </a:bodyPr>
+          <a:lstStyle/>
+          <a:p>
+            <a:pPr>
+              <a:spcAft>
+                <a:spcPts val="1600"/>
+              </a:spcAft>
+              <a:defRPr sz="2400" b="1">
+                <a:solidFill>
+                  <a:srgbClr val="F8FAFC"/>
+                </a:solidFill>
+              </a:defRPr>
+            </a:pPr>
+            <a:r>
+              <a:t>Core Solution Strategy</a:t>
+            </a:r>
+          </a:p>
+          <a:p>
+            <a:pPr>
+              <a:spcAft>
+                <a:spcPts val="1200"/>
+              </a:spcAft>
+              <a:defRPr sz="1800">
+                <a:solidFill>
+                  <a:srgbClr val="E2E8F0"/>
+                </a:solidFill>
+              </a:defRPr>
+            </a:pPr>
+            <a:r>
+              <a:t>•  Pure Content-Based Filtering: Grounded strictly on CountVectorizer genre representations and Cosine Similarity.</a:t>
+            </a:r>
+          </a:p>
+          <a:p>
+            <a:pPr>
+              <a:spcAft>
+                <a:spcPts val="1200"/>
+              </a:spcAft>
+              <a:defRPr sz="1800">
+                <a:solidFill>
+                  <a:srgbClr val="E2E8F0"/>
+                </a:solidFill>
+              </a:defRPr>
+            </a:pPr>
+            <a:r>
+              <a:t>•  Reference-Item Architecture: Any selected or rated anime becomes the reference item to discover similar titles.</a:t>
+            </a:r>
+          </a:p>
+          <a:p>
+            <a:pPr>
+              <a:spcAft>
+                <a:spcPts val="1200"/>
+              </a:spcAft>
+              <a:defRPr sz="1800">
+                <a:solidFill>
+                  <a:srgbClr val="E2E8F0"/>
+                </a:solidFill>
+              </a:defRPr>
+            </a:pPr>
+            <a:r>
+              <a:t>•  No Rating Weighting: Star ratings indicate user selection/like; strictly eliminates arbitrary Rating - 3.0 math.</a:t>
+            </a:r>
+          </a:p>
+          <a:p>
+            <a:pPr>
+              <a:spcAft>
+                <a:spcPts val="1200"/>
+              </a:spcAft>
+              <a:defRPr sz="1800">
+                <a:solidFill>
+                  <a:srgbClr val="E2E8F0"/>
+                </a:solidFill>
+              </a:defRPr>
+            </a:pPr>
+            <a:r>
+              <a:t>•  Transparent &amp; Explainable: Recommends Top-N similar titles with exact cosine similarity scores and visible genre tags.</a:t>
+            </a:r>
+          </a:p>
+        </p:txBody>
+      </p:sp>
+      <p:sp>
+        <p:nvSpPr>
+          <p:cNvPr id="10" name="Rounded Rectangle 9"/>
           <p:cNvSpPr/>
           <p:nvPr/>
         </p:nvSpPr>
@@ -6962,7 +7701,7 @@
       </p:sp>
       <p:sp>
         <p:nvSpPr>
-          <p:cNvPr id="7" name="TextBox 6"/>
+          <p:cNvPr id="11" name="TextBox 10"/>
           <p:cNvSpPr txBox="1"/>
           <p:nvPr/>
         </p:nvSpPr>
@@ -7060,7 +7799,7 @@
       </p:sp>
       <p:sp>
         <p:nvSpPr>
-          <p:cNvPr id="8" name="Rounded Rectangle 7"/>
+          <p:cNvPr id="12" name="Rounded Rectangle 11"/>
           <p:cNvSpPr/>
           <p:nvPr/>
         </p:nvSpPr>
@@ -7105,7 +7844,7 @@
       </p:sp>
       <p:sp>
         <p:nvSpPr>
-          <p:cNvPr id="9" name="TextBox 8"/>
+          <p:cNvPr id="13" name="TextBox 12"/>
           <p:cNvSpPr txBox="1"/>
           <p:nvPr/>
         </p:nvSpPr>
@@ -7293,7 +8032,7 @@
               </a:defRPr>
             </a:pPr>
             <a:r>
-              <a:t>PROJECT VISION &amp; ARCHITECTURE</a:t>
+              <a:t>PROBLEM STATEMENT &amp; MOTIVATION</a:t>
             </a:r>
           </a:p>
         </p:txBody>
@@ -7329,7 +8068,7 @@
               </a:defRPr>
             </a:pPr>
             <a:r>
-              <a:t>The ANIVIBE Solution</a:t>
+              <a:t>The 'Paradox of Choice' in Streaming</a:t>
             </a:r>
           </a:p>
         </p:txBody>
@@ -7365,150 +8104,7 @@
               </a:defRPr>
             </a:pPr>
             <a:r>
-              <a:t>A dual-purpose platform combining personal taste with situational decision rules.</a:t>
-            </a:r>
-          </a:p>
-        </p:txBody>
-      </p:sp>
-      <p:sp>
-        <p:nvSpPr>
-          <p:cNvPr id="6" name="Rounded Rectangle 5"/>
-          <p:cNvSpPr/>
-          <p:nvPr/>
-        </p:nvSpPr>
-        <p:spPr>
-          <a:xfrm>
-            <a:off x="731520" y="1965960"/>
-            <a:ext cx="10728655" cy="4297680"/>
-          </a:xfrm>
-          <a:prstGeom prst="roundRect">
-            <a:avLst/>
-          </a:prstGeom>
-          <a:solidFill>
-            <a:srgbClr val="1E293B"/>
-          </a:solidFill>
-          <a:ln w="19050">
-            <a:solidFill>
-              <a:srgbClr val="6366F1"/>
-            </a:solidFill>
-          </a:ln>
-        </p:spPr>
-        <p:style>
-          <a:lnRef idx="1">
-            <a:schemeClr val="accent1"/>
-          </a:lnRef>
-          <a:fillRef idx="3">
-            <a:schemeClr val="accent1"/>
-          </a:fillRef>
-          <a:effectRef idx="2">
-            <a:schemeClr val="accent1"/>
-          </a:effectRef>
-          <a:fontRef idx="minor">
-            <a:schemeClr val="lt1"/>
-          </a:fontRef>
-        </p:style>
-        <p:txBody>
-          <a:bodyPr rtlCol="0" anchor="ctr"/>
-          <a:lstStyle/>
-          <a:p>
-            <a:pPr algn="ctr"/>
-          </a:p>
-        </p:txBody>
-      </p:sp>
-      <p:sp>
-        <p:nvSpPr>
-          <p:cNvPr id="7" name="TextBox 6"/>
-          <p:cNvSpPr txBox="1"/>
-          <p:nvPr/>
-        </p:nvSpPr>
-        <p:spPr>
-          <a:xfrm>
-            <a:off x="1097280" y="2331720"/>
-            <a:ext cx="9997135" cy="3566160"/>
-          </a:xfrm>
-          <a:prstGeom prst="rect">
-            <a:avLst/>
-          </a:prstGeom>
-          <a:noFill/>
-        </p:spPr>
-        <p:txBody>
-          <a:bodyPr wrap="square">
-            <a:spAutoFit/>
-          </a:bodyPr>
-          <a:lstStyle/>
-          <a:p>
-            <a:pPr>
-              <a:spcAft>
-                <a:spcPts val="2000"/>
-              </a:spcAft>
-              <a:defRPr sz="2600" b="1">
-                <a:solidFill>
-                  <a:srgbClr val="F8FAFC"/>
-                </a:solidFill>
-              </a:defRPr>
-            </a:pPr>
-            <a:r>
-              <a:t>How ANIVIBE Bridges Taste and Situation</a:t>
-            </a:r>
-          </a:p>
-          <a:p>
-            <a:pPr>
-              <a:spcAft>
-                <a:spcPts val="1400"/>
-              </a:spcAft>
-              <a:defRPr sz="1900">
-                <a:solidFill>
-                  <a:srgbClr val="E2E8F0"/>
-                </a:solidFill>
-              </a:defRPr>
-            </a:pPr>
-            <a:r>
-              <a:t>•  1. Taste Profile (Content-Based): Learns your favorite genres dynamically from your 1-to-5 star ratings without requiring fake synthetic user accounts.</a:t>
-            </a:r>
-          </a:p>
-          <a:p>
-            <a:pPr>
-              <a:spcAft>
-                <a:spcPts val="1400"/>
-              </a:spcAft>
-              <a:defRPr sz="1900">
-                <a:solidFill>
-                  <a:srgbClr val="E2E8F0"/>
-                </a:solidFill>
-              </a:defRPr>
-            </a:pPr>
-            <a:r>
-              <a:t>•  2. Real-World Constraints (Knowledge-Based): Filters titles based on your current time budget (episode count), minimum score, and viewing mood.</a:t>
-            </a:r>
-          </a:p>
-          <a:p>
-            <a:pPr>
-              <a:spcAft>
-                <a:spcPts val="1400"/>
-              </a:spcAft>
-              <a:defRPr sz="1900">
-                <a:solidFill>
-                  <a:srgbClr val="E2E8F0"/>
-                </a:solidFill>
-              </a:defRPr>
-            </a:pPr>
-            <a:r>
-              <a:t>•  3. 1+1 Hybrid Fusion ('Smart Match'): Combines 50% Personal Taste with 50% Situational Fit into a unified score so every recommendation fits both your taste and your schedule.</a:t>
-            </a:r>
-          </a:p>
-          <a:p>
-            <a:pPr>
-              <a:spcAft>
-                <a:spcPts val="1400"/>
-              </a:spcAft>
-              <a:defRPr sz="1900">
-                <a:solidFill>
-                  <a:srgbClr val="E2E8F0"/>
-                </a:solidFill>
-              </a:defRPr>
-            </a:pPr>
-            <a:r>
-              <a:t>•  4. Transparent Explainability: Provides clear checklists showing why an anime matched or was excluded, eliminating black-box mystery.</a:t>
+              <a:t>Why viewers struggle to pick an anime, and why typical recommenders fail.</a:t>
             </a:r>
           </a:p>
         </p:txBody>
@@ -7605,7 +8201,7 @@
               </a:defRPr>
             </a:pPr>
             <a:r>
-              <a:t>CORE ENGINEERING</a:t>
+              <a:t>PROJECT VISION &amp; ARCHITECTURE</a:t>
             </a:r>
           </a:p>
         </p:txBody>
@@ -7641,7 +8237,7 @@
               </a:defRPr>
             </a:pPr>
             <a:r>
-              <a:t>4 Distinct Recommendation Paradigms</a:t>
+              <a:t>The ANIVIBE Solution</a:t>
             </a:r>
           </a:p>
         </p:txBody>
@@ -7677,7 +8273,7 @@
               </a:defRPr>
             </a:pPr>
             <a:r>
-              <a:t>Strict academic separation between consensus, taste, rules, and hybrid fusion.</a:t>
+              <a:t>A dual-purpose platform combining personal taste with situational decision rules.</a:t>
             </a:r>
           </a:p>
         </p:txBody>
@@ -7691,7 +8287,7 @@
         <p:spPr>
           <a:xfrm>
             <a:off x="731520" y="1965960"/>
-            <a:ext cx="5166360" cy="2011680"/>
+            <a:ext cx="10728655" cy="4297680"/>
           </a:xfrm>
           <a:prstGeom prst="roundRect">
             <a:avLst/>
@@ -7701,7 +8297,7 @@
           </a:solidFill>
           <a:ln w="19050">
             <a:solidFill>
-              <a:srgbClr val="F59E0B"/>
+              <a:srgbClr val="6366F1"/>
             </a:solidFill>
           </a:ln>
         </p:spPr>
@@ -7735,8 +8331,8 @@
         </p:nvSpPr>
         <p:spPr>
           <a:xfrm>
-            <a:off x="960120" y="2148840"/>
-            <a:ext cx="4709160" cy="1645920"/>
+            <a:off x="1097280" y="2331720"/>
+            <a:ext cx="9997135" cy="3566160"/>
           </a:xfrm>
           <a:prstGeom prst="rect">
             <a:avLst/>
@@ -7751,313 +8347,76 @@
           <a:p>
             <a:pPr>
               <a:spcAft>
-                <a:spcPts val="800"/>
-              </a:spcAft>
-              <a:defRPr sz="2000" b="1">
-                <a:solidFill>
-                  <a:srgbClr val="F59E0B"/>
-                </a:solidFill>
-              </a:defRPr>
-            </a:pPr>
-            <a:r>
-              <a:t>1. Popularity Baseline • Consensus Ranking</a:t>
-            </a:r>
-          </a:p>
-          <a:p>
-            <a:pPr>
-              <a:defRPr sz="1800">
+                <a:spcPts val="2000"/>
+              </a:spcAft>
+              <a:defRPr sz="2600" b="1">
+                <a:solidFill>
+                  <a:srgbClr val="F8FAFC"/>
+                </a:solidFill>
+              </a:defRPr>
+            </a:pPr>
+            <a:r>
+              <a:t>How ANIVIBE Bridges Taste and Situation</a:t>
+            </a:r>
+          </a:p>
+          <a:p>
+            <a:pPr>
+              <a:spcAft>
+                <a:spcPts val="1400"/>
+              </a:spcAft>
+              <a:defRPr sz="1900">
                 <a:solidFill>
                   <a:srgbClr val="E2E8F0"/>
                 </a:solidFill>
               </a:defRPr>
             </a:pPr>
             <a:r>
-              <a:t>Uses Bayesian smoothing to rank globally loved anime. Serves as the cold-start baseline for new visitors with 0 ratings.</a:t>
-            </a:r>
-          </a:p>
-        </p:txBody>
-      </p:sp>
-      <p:sp>
-        <p:nvSpPr>
-          <p:cNvPr id="8" name="Rounded Rectangle 7"/>
-          <p:cNvSpPr/>
-          <p:nvPr/>
-        </p:nvSpPr>
-        <p:spPr>
-          <a:xfrm>
-            <a:off x="6293815" y="1965960"/>
-            <a:ext cx="5166360" cy="2011680"/>
-          </a:xfrm>
-          <a:prstGeom prst="roundRect">
-            <a:avLst/>
-          </a:prstGeom>
-          <a:solidFill>
-            <a:srgbClr val="1E293B"/>
-          </a:solidFill>
-          <a:ln w="19050">
-            <a:solidFill>
-              <a:srgbClr val="A855F7"/>
-            </a:solidFill>
-          </a:ln>
-        </p:spPr>
-        <p:style>
-          <a:lnRef idx="1">
-            <a:schemeClr val="accent1"/>
-          </a:lnRef>
-          <a:fillRef idx="3">
-            <a:schemeClr val="accent1"/>
-          </a:fillRef>
-          <a:effectRef idx="2">
-            <a:schemeClr val="accent1"/>
-          </a:effectRef>
-          <a:fontRef idx="minor">
-            <a:schemeClr val="lt1"/>
-          </a:fontRef>
-        </p:style>
-        <p:txBody>
-          <a:bodyPr rtlCol="0" anchor="ctr"/>
-          <a:lstStyle/>
-          <a:p>
-            <a:pPr algn="ctr"/>
-          </a:p>
-        </p:txBody>
-      </p:sp>
-      <p:sp>
-        <p:nvSpPr>
-          <p:cNvPr id="9" name="TextBox 8"/>
-          <p:cNvSpPr txBox="1"/>
-          <p:nvPr/>
-        </p:nvSpPr>
-        <p:spPr>
-          <a:xfrm>
-            <a:off x="6522415" y="2148840"/>
-            <a:ext cx="4709160" cy="1645920"/>
-          </a:xfrm>
-          <a:prstGeom prst="rect">
-            <a:avLst/>
-          </a:prstGeom>
-          <a:noFill/>
-        </p:spPr>
-        <p:txBody>
-          <a:bodyPr wrap="square">
-            <a:spAutoFit/>
-          </a:bodyPr>
-          <a:lstStyle/>
-          <a:p>
-            <a:pPr>
-              <a:spcAft>
-                <a:spcPts val="800"/>
-              </a:spcAft>
-              <a:defRPr sz="2000" b="1">
-                <a:solidFill>
-                  <a:srgbClr val="A855F7"/>
-                </a:solidFill>
-              </a:defRPr>
-            </a:pPr>
-            <a:r>
-              <a:t>2. Content-Based Filtering • Genre Vector Space Model</a:t>
-            </a:r>
-          </a:p>
-          <a:p>
-            <a:pPr>
-              <a:defRPr sz="1800">
+              <a:t>•  1. Taste Profile (Content-Based): Learns your favorite genres dynamically from your 1-to-5 star ratings without requiring fake synthetic user accounts.</a:t>
+            </a:r>
+          </a:p>
+          <a:p>
+            <a:pPr>
+              <a:spcAft>
+                <a:spcPts val="1400"/>
+              </a:spcAft>
+              <a:defRPr sz="1900">
                 <a:solidFill>
                   <a:srgbClr val="E2E8F0"/>
                 </a:solidFill>
               </a:defRPr>
             </a:pPr>
             <a:r>
-              <a:t>Calculates cosine similarity across 29 genres. Powers 'More Like This' and builds user taste vectors from active ratings.</a:t>
-            </a:r>
-          </a:p>
-        </p:txBody>
-      </p:sp>
-      <p:sp>
-        <p:nvSpPr>
-          <p:cNvPr id="10" name="Rounded Rectangle 9"/>
-          <p:cNvSpPr/>
-          <p:nvPr/>
-        </p:nvSpPr>
-        <p:spPr>
-          <a:xfrm>
-            <a:off x="731520" y="4251960"/>
-            <a:ext cx="5166360" cy="2011680"/>
-          </a:xfrm>
-          <a:prstGeom prst="roundRect">
-            <a:avLst/>
-          </a:prstGeom>
-          <a:solidFill>
-            <a:srgbClr val="1E293B"/>
-          </a:solidFill>
-          <a:ln w="19050">
-            <a:solidFill>
-              <a:srgbClr val="06B6D4"/>
-            </a:solidFill>
-          </a:ln>
-        </p:spPr>
-        <p:style>
-          <a:lnRef idx="1">
-            <a:schemeClr val="accent1"/>
-          </a:lnRef>
-          <a:fillRef idx="3">
-            <a:schemeClr val="accent1"/>
-          </a:fillRef>
-          <a:effectRef idx="2">
-            <a:schemeClr val="accent1"/>
-          </a:effectRef>
-          <a:fontRef idx="minor">
-            <a:schemeClr val="lt1"/>
-          </a:fontRef>
-        </p:style>
-        <p:txBody>
-          <a:bodyPr rtlCol="0" anchor="ctr"/>
-          <a:lstStyle/>
-          <a:p>
-            <a:pPr algn="ctr"/>
-          </a:p>
-        </p:txBody>
-      </p:sp>
-      <p:sp>
-        <p:nvSpPr>
-          <p:cNvPr id="11" name="TextBox 10"/>
-          <p:cNvSpPr txBox="1"/>
-          <p:nvPr/>
-        </p:nvSpPr>
-        <p:spPr>
-          <a:xfrm>
-            <a:off x="960120" y="4434840"/>
-            <a:ext cx="4709160" cy="1645920"/>
-          </a:xfrm>
-          <a:prstGeom prst="rect">
-            <a:avLst/>
-          </a:prstGeom>
-          <a:noFill/>
-        </p:spPr>
-        <p:txBody>
-          <a:bodyPr wrap="square">
-            <a:spAutoFit/>
-          </a:bodyPr>
-          <a:lstStyle/>
-          <a:p>
-            <a:pPr>
-              <a:spcAft>
-                <a:spcPts val="800"/>
-              </a:spcAft>
-              <a:defRPr sz="2000" b="1">
-                <a:solidFill>
-                  <a:srgbClr val="06B6D4"/>
-                </a:solidFill>
-              </a:defRPr>
-            </a:pPr>
-            <a:r>
-              <a:t>3. Knowledge-Based Recommendation • Constraint Satisfaction &amp; Rules</a:t>
-            </a:r>
-          </a:p>
-          <a:p>
-            <a:pPr>
-              <a:defRPr sz="1800">
+              <a:t>•  2. Real-World Constraints (Knowledge-Based): Filters titles based on your current time budget (episode count), minimum score, and viewing mood.</a:t>
+            </a:r>
+          </a:p>
+          <a:p>
+            <a:pPr>
+              <a:spcAft>
+                <a:spcPts val="1400"/>
+              </a:spcAft>
+              <a:defRPr sz="1900">
                 <a:solidFill>
                   <a:srgbClr val="E2E8F0"/>
                 </a:solidFill>
               </a:defRPr>
             </a:pPr>
             <a:r>
-              <a:t>Filters candidate anime using hard limits (episodes, rating) and soft domain rules (viewing mood) with clear explanations.</a:t>
-            </a:r>
-          </a:p>
-        </p:txBody>
-      </p:sp>
-      <p:sp>
-        <p:nvSpPr>
-          <p:cNvPr id="12" name="Rounded Rectangle 11"/>
-          <p:cNvSpPr/>
-          <p:nvPr/>
-        </p:nvSpPr>
-        <p:spPr>
-          <a:xfrm>
-            <a:off x="6293815" y="4251960"/>
-            <a:ext cx="5166360" cy="2011680"/>
-          </a:xfrm>
-          <a:prstGeom prst="roundRect">
-            <a:avLst/>
-          </a:prstGeom>
-          <a:solidFill>
-            <a:srgbClr val="1E293B"/>
-          </a:solidFill>
-          <a:ln w="19050">
-            <a:solidFill>
-              <a:srgbClr val="10B981"/>
-            </a:solidFill>
-          </a:ln>
-        </p:spPr>
-        <p:style>
-          <a:lnRef idx="1">
-            <a:schemeClr val="accent1"/>
-          </a:lnRef>
-          <a:fillRef idx="3">
-            <a:schemeClr val="accent1"/>
-          </a:fillRef>
-          <a:effectRef idx="2">
-            <a:schemeClr val="accent1"/>
-          </a:effectRef>
-          <a:fontRef idx="minor">
-            <a:schemeClr val="lt1"/>
-          </a:fontRef>
-        </p:style>
-        <p:txBody>
-          <a:bodyPr rtlCol="0" anchor="ctr"/>
-          <a:lstStyle/>
-          <a:p>
-            <a:pPr algn="ctr"/>
-          </a:p>
-        </p:txBody>
-      </p:sp>
-      <p:sp>
-        <p:nvSpPr>
-          <p:cNvPr id="13" name="TextBox 12"/>
-          <p:cNvSpPr txBox="1"/>
-          <p:nvPr/>
-        </p:nvSpPr>
-        <p:spPr>
-          <a:xfrm>
-            <a:off x="6522415" y="4434840"/>
-            <a:ext cx="4709160" cy="1645920"/>
-          </a:xfrm>
-          <a:prstGeom prst="rect">
-            <a:avLst/>
-          </a:prstGeom>
-          <a:noFill/>
-        </p:spPr>
-        <p:txBody>
-          <a:bodyPr wrap="square">
-            <a:spAutoFit/>
-          </a:bodyPr>
-          <a:lstStyle/>
-          <a:p>
-            <a:pPr>
-              <a:spcAft>
-                <a:spcPts val="800"/>
-              </a:spcAft>
-              <a:defRPr sz="2000" b="1">
-                <a:solidFill>
-                  <a:srgbClr val="10B981"/>
-                </a:solidFill>
-              </a:defRPr>
-            </a:pPr>
-            <a:r>
-              <a:t>4. 1+1 Hybrid Fusion • Smart Match Engine</a:t>
-            </a:r>
-          </a:p>
-          <a:p>
-            <a:pPr>
-              <a:defRPr sz="1800">
+              <a:t>•  3. 1+1 Hybrid Fusion ('Smart Match'): Combines 50% Personal Taste with 50% Situational Fit into a unified score so every recommendation fits both your taste and your schedule.</a:t>
+            </a:r>
+          </a:p>
+          <a:p>
+            <a:pPr>
+              <a:spcAft>
+                <a:spcPts val="1400"/>
+              </a:spcAft>
+              <a:defRPr sz="1900">
                 <a:solidFill>
                   <a:srgbClr val="E2E8F0"/>
                 </a:solidFill>
               </a:defRPr>
             </a:pPr>
             <a:r>
-              <a:t>Equally combines 50% User Taste with 50% Situational Fit. Solves overspecialization and provides personalized results.</a:t>
+              <a:t>•  4. Transparent Explainability: Provides clear checklists showing why an anime matched or was excluded, eliminating black-box mystery.</a:t>
             </a:r>
           </a:p>
         </p:txBody>
@@ -8154,7 +8513,7 @@
               </a:defRPr>
             </a:pPr>
             <a:r>
-              <a:t>DATA ENGINEERING</a:t>
+              <a:t>CORE ENGINEERING</a:t>
             </a:r>
           </a:p>
         </p:txBody>
@@ -8190,7 +8549,7 @@
               </a:defRPr>
             </a:pPr>
             <a:r>
-              <a:t>Dataset &amp; Preprocessing Pipeline</a:t>
+              <a:t>4 Distinct Recommendation Paradigms</a:t>
             </a:r>
           </a:p>
         </p:txBody>
@@ -8226,7 +8585,7 @@
               </a:defRPr>
             </a:pPr>
             <a:r>
-              <a:t>Authentic Crunchyroll streaming dataset with zero synthetic users.</a:t>
+              <a:t>Strict academic separation between consensus, taste, rules, and hybrid fusion.</a:t>
             </a:r>
           </a:p>
         </p:txBody>
@@ -8250,7 +8609,7 @@
           </a:solidFill>
           <a:ln w="19050">
             <a:solidFill>
-              <a:srgbClr val="6366F1"/>
+              <a:srgbClr val="F59E0B"/>
             </a:solidFill>
           </a:ln>
         </p:spPr>
@@ -8284,8 +8643,8 @@
         </p:nvSpPr>
         <p:spPr>
           <a:xfrm>
-            <a:off x="1005840" y="2286000"/>
-            <a:ext cx="4617720" cy="1371600"/>
+            <a:off x="960120" y="2148840"/>
+            <a:ext cx="4709160" cy="1645920"/>
           </a:xfrm>
           <a:prstGeom prst="rect">
             <a:avLst/>
@@ -8300,23 +8659,20 @@
           <a:p>
             <a:pPr>
               <a:spcAft>
-                <a:spcPts val="1600"/>
-              </a:spcAft>
-              <a:defRPr sz="2400" b="1">
-                <a:solidFill>
-                  <a:srgbClr val="F8FAFC"/>
-                </a:solidFill>
-              </a:defRPr>
-            </a:pPr>
-            <a:r>
-              <a:t>Dataset Highlights</a:t>
-            </a:r>
-          </a:p>
-          <a:p>
-            <a:pPr>
-              <a:spcAft>
-                <a:spcPts val="1200"/>
-              </a:spcAft>
+                <a:spcPts val="800"/>
+              </a:spcAft>
+              <a:defRPr sz="2000" b="1">
+                <a:solidFill>
+                  <a:srgbClr val="F59E0B"/>
+                </a:solidFill>
+              </a:defRPr>
+            </a:pPr>
+            <a:r>
+              <a:t>1. Popularity Baseline • Consensus Ranking</a:t>
+            </a:r>
+          </a:p>
+          <a:p>
+            <a:pPr>
               <a:defRPr sz="1800">
                 <a:solidFill>
                   <a:srgbClr val="E2E8F0"/>
@@ -8324,52 +8680,7 @@
               </a:defRPr>
             </a:pPr>
             <a:r>
-              <a:t>•  1,255 Cleaned Anime Titles: Complete metadata from the Crunchyroll catalog including synopsis, artwork, and episodes.</a:t>
-            </a:r>
-          </a:p>
-          <a:p>
-            <a:pPr>
-              <a:spcAft>
-                <a:spcPts val="1200"/>
-              </a:spcAft>
-              <a:defRPr sz="1800">
-                <a:solidFill>
-                  <a:srgbClr val="E2E8F0"/>
-                </a:solidFill>
-              </a:defRPr>
-            </a:pPr>
-            <a:r>
-              <a:t>•  29 Binary Genre Features: Each anime is encoded into a 29-dimensional vector (Action, Shonen, Romance, Sci-Fi, etc.).</a:t>
-            </a:r>
-          </a:p>
-          <a:p>
-            <a:pPr>
-              <a:spcAft>
-                <a:spcPts val="1200"/>
-              </a:spcAft>
-              <a:defRPr sz="1800">
-                <a:solidFill>
-                  <a:srgbClr val="E2E8F0"/>
-                </a:solidFill>
-              </a:defRPr>
-            </a:pPr>
-            <a:r>
-              <a:t>•  18,500+ Community Ratings: Authentic multi-star distribution histograms (1★ to 5★ votes) for every anime.</a:t>
-            </a:r>
-          </a:p>
-          <a:p>
-            <a:pPr>
-              <a:spcAft>
-                <a:spcPts val="1200"/>
-              </a:spcAft>
-              <a:defRPr sz="1800">
-                <a:solidFill>
-                  <a:srgbClr val="E2E8F0"/>
-                </a:solidFill>
-              </a:defRPr>
-            </a:pPr>
-            <a:r>
-              <a:t>•  Zero Synthetic Users: All user tests are based on real interaction sessions, preserving academic integrity.</a:t>
+              <a:t>Uses Bayesian smoothing to rank globally loved anime. Serves as the cold-start baseline for new visitors with 0 ratings.</a:t>
             </a:r>
           </a:p>
         </p:txBody>
@@ -8383,6 +8694,196 @@
         <p:spPr>
           <a:xfrm>
             <a:off x="6293815" y="1965960"/>
+            <a:ext cx="5166360" cy="2011680"/>
+          </a:xfrm>
+          <a:prstGeom prst="roundRect">
+            <a:avLst/>
+          </a:prstGeom>
+          <a:solidFill>
+            <a:srgbClr val="1E293B"/>
+          </a:solidFill>
+          <a:ln w="19050">
+            <a:solidFill>
+              <a:srgbClr val="A855F7"/>
+            </a:solidFill>
+          </a:ln>
+        </p:spPr>
+        <p:style>
+          <a:lnRef idx="1">
+            <a:schemeClr val="accent1"/>
+          </a:lnRef>
+          <a:fillRef idx="3">
+            <a:schemeClr val="accent1"/>
+          </a:fillRef>
+          <a:effectRef idx="2">
+            <a:schemeClr val="accent1"/>
+          </a:effectRef>
+          <a:fontRef idx="minor">
+            <a:schemeClr val="lt1"/>
+          </a:fontRef>
+        </p:style>
+        <p:txBody>
+          <a:bodyPr rtlCol="0" anchor="ctr"/>
+          <a:lstStyle/>
+          <a:p>
+            <a:pPr algn="ctr"/>
+          </a:p>
+        </p:txBody>
+      </p:sp>
+      <p:sp>
+        <p:nvSpPr>
+          <p:cNvPr id="9" name="TextBox 8"/>
+          <p:cNvSpPr txBox="1"/>
+          <p:nvPr/>
+        </p:nvSpPr>
+        <p:spPr>
+          <a:xfrm>
+            <a:off x="6522415" y="2148840"/>
+            <a:ext cx="4709160" cy="1645920"/>
+          </a:xfrm>
+          <a:prstGeom prst="rect">
+            <a:avLst/>
+          </a:prstGeom>
+          <a:noFill/>
+        </p:spPr>
+        <p:txBody>
+          <a:bodyPr wrap="square">
+            <a:spAutoFit/>
+          </a:bodyPr>
+          <a:lstStyle/>
+          <a:p>
+            <a:pPr>
+              <a:spcAft>
+                <a:spcPts val="800"/>
+              </a:spcAft>
+              <a:defRPr sz="2000" b="1">
+                <a:solidFill>
+                  <a:srgbClr val="A855F7"/>
+                </a:solidFill>
+              </a:defRPr>
+            </a:pPr>
+            <a:r>
+              <a:t>2. Content-Based Filtering • Genre Vector Space Model</a:t>
+            </a:r>
+          </a:p>
+          <a:p>
+            <a:pPr>
+              <a:defRPr sz="1800">
+                <a:solidFill>
+                  <a:srgbClr val="E2E8F0"/>
+                </a:solidFill>
+              </a:defRPr>
+            </a:pPr>
+            <a:r>
+              <a:t>Calculates cosine similarity across 29 genres. Powers 'More Like This' and builds user taste vectors from active ratings.</a:t>
+            </a:r>
+          </a:p>
+        </p:txBody>
+      </p:sp>
+      <p:sp>
+        <p:nvSpPr>
+          <p:cNvPr id="10" name="Rounded Rectangle 9"/>
+          <p:cNvSpPr/>
+          <p:nvPr/>
+        </p:nvSpPr>
+        <p:spPr>
+          <a:xfrm>
+            <a:off x="731520" y="4251960"/>
+            <a:ext cx="5166360" cy="2011680"/>
+          </a:xfrm>
+          <a:prstGeom prst="roundRect">
+            <a:avLst/>
+          </a:prstGeom>
+          <a:solidFill>
+            <a:srgbClr val="1E293B"/>
+          </a:solidFill>
+          <a:ln w="19050">
+            <a:solidFill>
+              <a:srgbClr val="06B6D4"/>
+            </a:solidFill>
+          </a:ln>
+        </p:spPr>
+        <p:style>
+          <a:lnRef idx="1">
+            <a:schemeClr val="accent1"/>
+          </a:lnRef>
+          <a:fillRef idx="3">
+            <a:schemeClr val="accent1"/>
+          </a:fillRef>
+          <a:effectRef idx="2">
+            <a:schemeClr val="accent1"/>
+          </a:effectRef>
+          <a:fontRef idx="minor">
+            <a:schemeClr val="lt1"/>
+          </a:fontRef>
+        </p:style>
+        <p:txBody>
+          <a:bodyPr rtlCol="0" anchor="ctr"/>
+          <a:lstStyle/>
+          <a:p>
+            <a:pPr algn="ctr"/>
+          </a:p>
+        </p:txBody>
+      </p:sp>
+      <p:sp>
+        <p:nvSpPr>
+          <p:cNvPr id="11" name="TextBox 10"/>
+          <p:cNvSpPr txBox="1"/>
+          <p:nvPr/>
+        </p:nvSpPr>
+        <p:spPr>
+          <a:xfrm>
+            <a:off x="960120" y="4434840"/>
+            <a:ext cx="4709160" cy="1645920"/>
+          </a:xfrm>
+          <a:prstGeom prst="rect">
+            <a:avLst/>
+          </a:prstGeom>
+          <a:noFill/>
+        </p:spPr>
+        <p:txBody>
+          <a:bodyPr wrap="square">
+            <a:spAutoFit/>
+          </a:bodyPr>
+          <a:lstStyle/>
+          <a:p>
+            <a:pPr>
+              <a:spcAft>
+                <a:spcPts val="800"/>
+              </a:spcAft>
+              <a:defRPr sz="2000" b="1">
+                <a:solidFill>
+                  <a:srgbClr val="06B6D4"/>
+                </a:solidFill>
+              </a:defRPr>
+            </a:pPr>
+            <a:r>
+              <a:t>3. Knowledge-Based Recommendation • Constraint Satisfaction &amp; Rules</a:t>
+            </a:r>
+          </a:p>
+          <a:p>
+            <a:pPr>
+              <a:defRPr sz="1800">
+                <a:solidFill>
+                  <a:srgbClr val="E2E8F0"/>
+                </a:solidFill>
+              </a:defRPr>
+            </a:pPr>
+            <a:r>
+              <a:t>Filters candidate anime using hard limits (episodes, rating) and soft domain rules (viewing mood) with clear explanations.</a:t>
+            </a:r>
+          </a:p>
+        </p:txBody>
+      </p:sp>
+      <p:sp>
+        <p:nvSpPr>
+          <p:cNvPr id="12" name="Rounded Rectangle 11"/>
+          <p:cNvSpPr/>
+          <p:nvPr/>
+        </p:nvSpPr>
+        <p:spPr>
+          <a:xfrm>
+            <a:off x="6293815" y="4251960"/>
             <a:ext cx="5166360" cy="2011680"/>
           </a:xfrm>
           <a:prstGeom prst="roundRect">
@@ -8421,14 +8922,14 @@
       </p:sp>
       <p:sp>
         <p:nvSpPr>
-          <p:cNvPr id="9" name="TextBox 8"/>
+          <p:cNvPr id="13" name="TextBox 12"/>
           <p:cNvSpPr txBox="1"/>
           <p:nvPr/>
         </p:nvSpPr>
         <p:spPr>
           <a:xfrm>
-            <a:off x="6568135" y="2286000"/>
-            <a:ext cx="4617720" cy="1371600"/>
+            <a:off x="6522415" y="4434840"/>
+            <a:ext cx="4709160" cy="1645920"/>
           </a:xfrm>
           <a:prstGeom prst="rect">
             <a:avLst/>
@@ -8443,23 +8944,20 @@
           <a:p>
             <a:pPr>
               <a:spcAft>
-                <a:spcPts val="1600"/>
-              </a:spcAft>
-              <a:defRPr sz="2400" b="1">
-                <a:solidFill>
-                  <a:srgbClr val="F8FAFC"/>
-                </a:solidFill>
-              </a:defRPr>
-            </a:pPr>
-            <a:r>
-              <a:t>Evaluation Integrity</a:t>
-            </a:r>
-          </a:p>
-          <a:p>
-            <a:pPr>
-              <a:spcAft>
-                <a:spcPts val="1200"/>
-              </a:spcAft>
+                <a:spcPts val="800"/>
+              </a:spcAft>
+              <a:defRPr sz="2000" b="1">
+                <a:solidFill>
+                  <a:srgbClr val="10B981"/>
+                </a:solidFill>
+              </a:defRPr>
+            </a:pPr>
+            <a:r>
+              <a:t>4. 1+1 Hybrid Fusion • Smart Match Engine</a:t>
+            </a:r>
+          </a:p>
+          <a:p>
+            <a:pPr>
               <a:defRPr sz="1800">
                 <a:solidFill>
                   <a:srgbClr val="E2E8F0"/>
@@ -8467,52 +8965,7 @@
               </a:defRPr>
             </a:pPr>
             <a:r>
-              <a:t>•  80/20 Train-Test Split: 20% of ratings were held out in a test vault to simulate unobserved future choices.</a:t>
-            </a:r>
-          </a:p>
-          <a:p>
-            <a:pPr>
-              <a:spcAft>
-                <a:spcPts val="1200"/>
-              </a:spcAft>
-              <a:defRPr sz="1800">
-                <a:solidFill>
-                  <a:srgbClr val="E2E8F0"/>
-                </a:solidFill>
-              </a:defRPr>
-            </a:pPr>
-            <a:r>
-              <a:t>•  No Data Leakage: Evaluation metrics only test against the holdout set, guaranteeing objective benchmark scores.</a:t>
-            </a:r>
-          </a:p>
-          <a:p>
-            <a:pPr>
-              <a:spcAft>
-                <a:spcPts val="1200"/>
-              </a:spcAft>
-              <a:defRPr sz="1800">
-                <a:solidFill>
-                  <a:srgbClr val="E2E8F0"/>
-                </a:solidFill>
-              </a:defRPr>
-            </a:pPr>
-            <a:r>
-              <a:t>•  Vector Normalization: L2 Euclidean normalization is applied to genre vectors to ensure fair cosine similarity comparisons.</a:t>
-            </a:r>
-          </a:p>
-          <a:p>
-            <a:pPr>
-              <a:spcAft>
-                <a:spcPts val="1200"/>
-              </a:spcAft>
-              <a:defRPr sz="1800">
-                <a:solidFill>
-                  <a:srgbClr val="E2E8F0"/>
-                </a:solidFill>
-              </a:defRPr>
-            </a:pPr>
-            <a:r>
-              <a:t>•  Lightweight Catalog (&lt; 1 MB): Optimized JSON format loads in milliseconds and runs directly in the browser.</a:t>
+              <a:t>Equally combines 50% User Taste with 50% Situational Fit. Solves overspecialization and provides personalized results.</a:t>
             </a:r>
           </a:p>
         </p:txBody>
@@ -8609,7 +9062,7 @@
               </a:defRPr>
             </a:pPr>
             <a:r>
-              <a:t>RECOMMENDATION PARADIGM 1</a:t>
+              <a:t>DATA ENGINEERING</a:t>
             </a:r>
           </a:p>
         </p:txBody>
@@ -8645,7 +9098,7 @@
               </a:defRPr>
             </a:pPr>
             <a:r>
-              <a:t>Popularity Baseline (Bayesian Consensus)</a:t>
+              <a:t>Dataset &amp; Preprocessing Pipeline</a:t>
             </a:r>
           </a:p>
         </p:txBody>
@@ -8681,7 +9134,7 @@
               </a:defRPr>
             </a:pPr>
             <a:r>
-              <a:t>Solving low-sample rating bias with weighted Bayesian consensus ranking.</a:t>
+              <a:t>Authentic Crunchyroll streaming dataset with zero synthetic users.</a:t>
             </a:r>
           </a:p>
         </p:txBody>
@@ -8705,7 +9158,7 @@
           </a:solidFill>
           <a:ln w="19050">
             <a:solidFill>
-              <a:srgbClr val="F59E0B"/>
+              <a:srgbClr val="6366F1"/>
             </a:solidFill>
           </a:ln>
         </p:spPr>
@@ -8755,7 +9208,7 @@
           <a:p>
             <a:pPr>
               <a:spcAft>
-                <a:spcPts val="1400"/>
+                <a:spcPts val="1600"/>
               </a:spcAft>
               <a:defRPr sz="2400" b="1">
                 <a:solidFill>
@@ -8764,28 +9217,13 @@
               </a:defRPr>
             </a:pPr>
             <a:r>
-              <a:t>Bayesian Rating Formula</a:t>
-            </a:r>
-          </a:p>
-          <a:p>
-            <a:pPr>
-              <a:spcAft>
-                <a:spcPts val="1600"/>
-              </a:spcAft>
-              <a:defRPr sz="2000" b="1">
-                <a:solidFill>
-                  <a:srgbClr val="06B6D4"/>
-                </a:solidFill>
-              </a:defRPr>
-            </a:pPr>
-            <a:r>
-              <a:t>WR = ( v / (v + m) ) × R + ( m / (v + m) ) × C</a:t>
-            </a:r>
-          </a:p>
-          <a:p>
-            <a:pPr>
-              <a:spcAft>
-                <a:spcPts val="1000"/>
+              <a:t>Dataset Highlights</a:t>
+            </a:r>
+          </a:p>
+          <a:p>
+            <a:pPr>
+              <a:spcAft>
+                <a:spcPts val="1200"/>
               </a:spcAft>
               <a:defRPr sz="1800">
                 <a:solidFill>
@@ -8794,13 +9232,13 @@
               </a:defRPr>
             </a:pPr>
             <a:r>
-              <a:t>•  v = Number of ratings/votes for this anime</a:t>
-            </a:r>
-          </a:p>
-          <a:p>
-            <a:pPr>
-              <a:spcAft>
-                <a:spcPts val="1000"/>
+              <a:t>•  1,255 Cleaned Anime Titles: Complete metadata from the Crunchyroll catalog including synopsis, artwork, and episodes.</a:t>
+            </a:r>
+          </a:p>
+          <a:p>
+            <a:pPr>
+              <a:spcAft>
+                <a:spcPts val="1200"/>
               </a:spcAft>
               <a:defRPr sz="1800">
                 <a:solidFill>
@@ -8809,13 +9247,13 @@
               </a:defRPr>
             </a:pPr>
             <a:r>
-              <a:t>•  m = Minimum vote threshold prior (m = 100 votes)</a:t>
-            </a:r>
-          </a:p>
-          <a:p>
-            <a:pPr>
-              <a:spcAft>
-                <a:spcPts val="1000"/>
+              <a:t>•  29 Binary Genre Features: Each anime is encoded into a 29-dimensional vector (Action, Shonen, Romance, Sci-Fi, etc.).</a:t>
+            </a:r>
+          </a:p>
+          <a:p>
+            <a:pPr>
+              <a:spcAft>
+                <a:spcPts val="1200"/>
               </a:spcAft>
               <a:defRPr sz="1800">
                 <a:solidFill>
@@ -8824,13 +9262,13 @@
               </a:defRPr>
             </a:pPr>
             <a:r>
-              <a:t>•  R = Average viewer rating for this anime</a:t>
-            </a:r>
-          </a:p>
-          <a:p>
-            <a:pPr>
-              <a:spcAft>
-                <a:spcPts val="1000"/>
+              <a:t>•  18,500+ Community Ratings: Authentic multi-star distribution histograms (1★ to 5★ votes) for every anime.</a:t>
+            </a:r>
+          </a:p>
+          <a:p>
+            <a:pPr>
+              <a:spcAft>
+                <a:spcPts val="1200"/>
               </a:spcAft>
               <a:defRPr sz="1800">
                 <a:solidFill>
@@ -8839,22 +9277,7 @@
               </a:defRPr>
             </a:pPr>
             <a:r>
-              <a:t>•  C = Global mean rating across the entire catalog (C = 3.65)</a:t>
-            </a:r>
-          </a:p>
-          <a:p>
-            <a:pPr>
-              <a:spcAft>
-                <a:spcPts val="1000"/>
-              </a:spcAft>
-              <a:defRPr sz="1800">
-                <a:solidFill>
-                  <a:srgbClr val="E2E8F0"/>
-                </a:solidFill>
-              </a:defRPr>
-            </a:pPr>
-            <a:r>
-              <a:t>•  Weighted Consensus: As votes (v) increase, the score shifts smoothly from the global mean (C) to the anime's true rating (R).</a:t>
+              <a:t>•  Zero Synthetic Users: All user tests are based on real interaction sessions, preserving academic integrity.</a:t>
             </a:r>
           </a:p>
         </p:txBody>
@@ -8878,7 +9301,7 @@
           </a:solidFill>
           <a:ln w="19050">
             <a:solidFill>
-              <a:srgbClr val="334155"/>
+              <a:srgbClr val="10B981"/>
             </a:solidFill>
           </a:ln>
         </p:spPr>
@@ -8937,7 +9360,7 @@
               </a:defRPr>
             </a:pPr>
             <a:r>
-              <a:t>Why This Prevents Unfair Bias</a:t>
+              <a:t>Evaluation Integrity</a:t>
             </a:r>
           </a:p>
           <a:p>
@@ -8952,7 +9375,7 @@
               </a:defRPr>
             </a:pPr>
             <a:r>
-              <a:t>•  The 1-Vote Flaw: Without Bayesian smoothing, a movie with a single 5.0★ vote would rank #1 overall.</a:t>
+              <a:t>•  80/20 Train-Test Split: 20% of ratings were held out in a test vault to simulate unobserved future choices.</a:t>
             </a:r>
           </a:p>
           <a:p>
@@ -8967,7 +9390,7 @@
               </a:defRPr>
             </a:pPr>
             <a:r>
-              <a:t>•  The Solution: With m = 100, an anime with 1 vote of 5.0★ drops to WR ≈ 3.66★ (pulled toward average).</a:t>
+              <a:t>•  No Data Leakage: Evaluation metrics only test against the holdout set, guaranteeing objective benchmark scores.</a:t>
             </a:r>
           </a:p>
           <a:p>
@@ -8982,7 +9405,7 @@
               </a:defRPr>
             </a:pPr>
             <a:r>
-              <a:t>•  Fair Classic Recognition: A popular classic with 4.8★ across 50,000 votes achieves WR ≈ 4.80★.</a:t>
+              <a:t>•  Vector Normalization: L2 Euclidean normalization is applied to genre vectors to ensure fair cosine similarity comparisons.</a:t>
             </a:r>
           </a:p>
           <a:p>
@@ -8997,7 +9420,7 @@
               </a:defRPr>
             </a:pPr>
             <a:r>
-              <a:t>•  Role in ANIVIBE: Displayed on the Home page as 'Popular Right Now' to welcome new users with 0 ratings.</a:t>
+              <a:t>•  Lightweight Catalog (&lt; 1 MB): Optimized JSON format loads in milliseconds and runs directly in the browser.</a:t>
             </a:r>
           </a:p>
         </p:txBody>
@@ -9094,7 +9517,7 @@
               </a:defRPr>
             </a:pPr>
             <a:r>
-              <a:t>RECOMMENDATION PARADIGM 2A</a:t>
+              <a:t>RECOMMENDATION PARADIGM 1</a:t>
             </a:r>
           </a:p>
         </p:txBody>
@@ -9130,7 +9553,7 @@
               </a:defRPr>
             </a:pPr>
             <a:r>
-              <a:t>Content-Based Item Similarity</a:t>
+              <a:t>Popularity Baseline (Bayesian Consensus)</a:t>
             </a:r>
           </a:p>
         </p:txBody>
@@ -9166,7 +9589,7 @@
               </a:defRPr>
             </a:pPr>
             <a:r>
-              <a:t>Pairing anime using Cosine Similarity on 29-genre binary feature vectors.</a:t>
+              <a:t>Solving low-sample rating bias with weighted Bayesian consensus ranking.</a:t>
             </a:r>
           </a:p>
         </p:txBody>
@@ -9190,7 +9613,7 @@
           </a:solidFill>
           <a:ln w="19050">
             <a:solidFill>
-              <a:srgbClr val="A855F7"/>
+              <a:srgbClr val="F59E0B"/>
             </a:solidFill>
           </a:ln>
         </p:spPr>
@@ -9249,7 +9672,7 @@
               </a:defRPr>
             </a:pPr>
             <a:r>
-              <a:t>Cosine Similarity Math</a:t>
+              <a:t>Bayesian Rating Formula</a:t>
             </a:r>
           </a:p>
           <a:p>
@@ -9264,13 +9687,13 @@
               </a:defRPr>
             </a:pPr>
             <a:r>
-              <a:t>sim(A, B) = ( A • B ) / ( ||A|| × ||B|| )</a:t>
-            </a:r>
-          </a:p>
-          <a:p>
-            <a:pPr>
-              <a:spcAft>
-                <a:spcPts val="1200"/>
+              <a:t>WR = ( v / (v + m) ) × R + ( m / (v + m) ) × C</a:t>
+            </a:r>
+          </a:p>
+          <a:p>
+            <a:pPr>
+              <a:spcAft>
+                <a:spcPts val="1000"/>
               </a:spcAft>
               <a:defRPr sz="1800">
                 <a:solidFill>
@@ -9279,13 +9702,13 @@
               </a:defRPr>
             </a:pPr>
             <a:r>
-              <a:t>•  A and B are 29-dimensional binary vectors where 1 represents genre presence and 0 represents absence.</a:t>
-            </a:r>
-          </a:p>
-          <a:p>
-            <a:pPr>
-              <a:spcAft>
-                <a:spcPts val="1200"/>
+              <a:t>•  v = Number of ratings/votes for this anime</a:t>
+            </a:r>
+          </a:p>
+          <a:p>
+            <a:pPr>
+              <a:spcAft>
+                <a:spcPts val="1000"/>
               </a:spcAft>
               <a:defRPr sz="1800">
                 <a:solidFill>
@@ -9294,13 +9717,13 @@
               </a:defRPr>
             </a:pPr>
             <a:r>
-              <a:t>•  A • B computes the count of shared overlapping genres between the two titles.</a:t>
-            </a:r>
-          </a:p>
-          <a:p>
-            <a:pPr>
-              <a:spcAft>
-                <a:spcPts val="1200"/>
+              <a:t>•  m = Minimum vote threshold prior (m = 100 votes)</a:t>
+            </a:r>
+          </a:p>
+          <a:p>
+            <a:pPr>
+              <a:spcAft>
+                <a:spcPts val="1000"/>
               </a:spcAft>
               <a:defRPr sz="1800">
                 <a:solidFill>
@@ -9309,13 +9732,13 @@
               </a:defRPr>
             </a:pPr>
             <a:r>
-              <a:t>•  ||A|| × ||B|| normalizes the score by vector lengths so titles with many genres do not artificially dominate.</a:t>
-            </a:r>
-          </a:p>
-          <a:p>
-            <a:pPr>
-              <a:spcAft>
-                <a:spcPts val="1200"/>
+              <a:t>•  R = Average viewer rating for this anime</a:t>
+            </a:r>
+          </a:p>
+          <a:p>
+            <a:pPr>
+              <a:spcAft>
+                <a:spcPts val="1000"/>
               </a:spcAft>
               <a:defRPr sz="1800">
                 <a:solidFill>
@@ -9324,7 +9747,22 @@
               </a:defRPr>
             </a:pPr>
             <a:r>
-              <a:t>•  Produces an intuitive similarity percentage from 0% (no overlap) to 100% (identical genre fingerprint).</a:t>
+              <a:t>•  C = Global mean rating across the entire catalog (C = 3.65)</a:t>
+            </a:r>
+          </a:p>
+          <a:p>
+            <a:pPr>
+              <a:spcAft>
+                <a:spcPts val="1000"/>
+              </a:spcAft>
+              <a:defRPr sz="1800">
+                <a:solidFill>
+                  <a:srgbClr val="E2E8F0"/>
+                </a:solidFill>
+              </a:defRPr>
+            </a:pPr>
+            <a:r>
+              <a:t>•  Weighted Consensus: As votes (v) increase, the score shifts smoothly from the global mean (C) to the anime's true rating (R).</a:t>
             </a:r>
           </a:p>
         </p:txBody>
@@ -9407,7 +9845,7 @@
               </a:defRPr>
             </a:pPr>
             <a:r>
-              <a:t>How It Works on Detail Page</a:t>
+              <a:t>Why This Prevents Unfair Bias</a:t>
             </a:r>
           </a:p>
           <a:p>
@@ -9422,7 +9860,7 @@
               </a:defRPr>
             </a:pPr>
             <a:r>
-              <a:t>•  'More Like This' Row: Displayed on the Anime Detail page directly below the anime information.</a:t>
+              <a:t>•  The 1-Vote Flaw: Without Bayesian smoothing, a movie with a single 5.0★ vote would rank #1 overall.</a:t>
             </a:r>
           </a:p>
           <a:p>
@@ -9437,7 +9875,7 @@
               </a:defRPr>
             </a:pPr>
             <a:r>
-              <a:t>•  Netflix-Style Carousel: Shows recommendations in a single horizontal row with left/right navigation arrows.</a:t>
+              <a:t>•  The Solution: With m = 100, an anime with 1 vote of 5.0★ drops to WR ≈ 3.66★ (pulled toward average).</a:t>
             </a:r>
           </a:p>
           <a:p>
@@ -9452,7 +9890,7 @@
               </a:defRPr>
             </a:pPr>
             <a:r>
-              <a:t>•  Concrete Example: If viewing Naruto (Action, Shonen, Martial Arts), it recommends titles with identical high genre overlap.</a:t>
+              <a:t>•  Fair Classic Recognition: A popular classic with 4.8★ across 50,000 votes achieves WR ≈ 4.80★.</a:t>
             </a:r>
           </a:p>
           <a:p>
@@ -9467,7 +9905,7 @@
               </a:defRPr>
             </a:pPr>
             <a:r>
-              <a:t>•  Independent of User History: Lets users explore similar shows even before rating any titles.</a:t>
+              <a:t>•  Role in ANIVIBE: Displayed on the Home page as 'Popular Right Now' to welcome new users with 0 ratings.</a:t>
             </a:r>
           </a:p>
         </p:txBody>
@@ -9564,7 +10002,7 @@
               </a:defRPr>
             </a:pPr>
             <a:r>
-              <a:t>RECOMMENDATION PARADIGM 2B</a:t>
+              <a:t>RECOMMENDATION PARADIGM 2A</a:t>
             </a:r>
           </a:p>
         </p:txBody>
@@ -9600,7 +10038,7 @@
               </a:defRPr>
             </a:pPr>
             <a:r>
-              <a:t>Personalized Content-Based Filtering</a:t>
+              <a:t>Content-Based Filtering Core Method</a:t>
             </a:r>
           </a:p>
         </p:txBody>
@@ -9636,7 +10074,7 @@
               </a:defRPr>
             </a:pPr>
             <a:r>
-              <a:t>Dynamically learning user taste vectors from active 1-to-5 star ratings.</a:t>
+              <a:t>CountVectorizer feature matrix + Cosine Similarity on anime genres.</a:t>
             </a:r>
           </a:p>
         </p:txBody>
@@ -9660,7 +10098,7 @@
           </a:solidFill>
           <a:ln w="19050">
             <a:solidFill>
-              <a:srgbClr val="6366F1"/>
+              <a:srgbClr val="A855F7"/>
             </a:solidFill>
           </a:ln>
         </p:spPr>
@@ -9719,28 +10157,13 @@
               </a:defRPr>
             </a:pPr>
             <a:r>
-              <a:t>Centered Taste Weighting</a:t>
-            </a:r>
-          </a:p>
-          <a:p>
-            <a:pPr>
-              <a:spcAft>
-                <a:spcPts val="1600"/>
-              </a:spcAft>
-              <a:defRPr sz="2000" b="1">
-                <a:solidFill>
-                  <a:srgbClr val="10B981"/>
-                </a:solidFill>
-              </a:defRPr>
-            </a:pPr>
-            <a:r>
-              <a:t>Genre Weight = Rating − 3.0</a:t>
-            </a:r>
-          </a:p>
-          <a:p>
-            <a:pPr>
-              <a:spcAft>
-                <a:spcPts val="1000"/>
+              <a:t>CountVectorizer Genre Representation</a:t>
+            </a:r>
+          </a:p>
+          <a:p>
+            <a:pPr>
+              <a:spcAft>
+                <a:spcPts val="1200"/>
               </a:spcAft>
               <a:defRPr sz="1800">
                 <a:solidFill>
@@ -9749,13 +10172,13 @@
               </a:defRPr>
             </a:pPr>
             <a:r>
-              <a:t>•  5★ Rating = +2.0 (Strongly loved genre; heavy boost)</a:t>
-            </a:r>
-          </a:p>
-          <a:p>
-            <a:pPr>
-              <a:spcAft>
-                <a:spcPts val="1000"/>
+              <a:t>•  Genre Normalization: Clean and normalize genre text across all 1,255 anime (lowercase, whitespace stripping).</a:t>
+            </a:r>
+          </a:p>
+          <a:p>
+            <a:pPr>
+              <a:spcAft>
+                <a:spcPts val="1200"/>
               </a:spcAft>
               <a:defRPr sz="1800">
                 <a:solidFill>
@@ -9764,13 +10187,13 @@
               </a:defRPr>
             </a:pPr>
             <a:r>
-              <a:t>•  4★ Rating = +1.0 (Mild preference; positive boost)</a:t>
-            </a:r>
-          </a:p>
-          <a:p>
-            <a:pPr>
-              <a:spcAft>
-                <a:spcPts val="1000"/>
+              <a:t>•  sklearn CountVectorizer: Tokenizes anime genres into an exact 29-genre binary feature matrix.</a:t>
+            </a:r>
+          </a:p>
+          <a:p>
+            <a:pPr>
+              <a:spcAft>
+                <a:spcPts val="1200"/>
               </a:spcAft>
               <a:defRPr sz="1800">
                 <a:solidFill>
@@ -9779,13 +10202,13 @@
               </a:defRPr>
             </a:pPr>
             <a:r>
-              <a:t>•  3★ Rating = 0.0 (Neutral; zero effect on taste profile)</a:t>
-            </a:r>
-          </a:p>
-          <a:p>
-            <a:pPr>
-              <a:spcAft>
-                <a:spcPts val="1000"/>
+              <a:t>•  Genre Feature Vector: Each anime is represented as a 29-dimensional vector where 1 indicates genre presence and 0 indicates absence.</a:t>
+            </a:r>
+          </a:p>
+          <a:p>
+            <a:pPr>
+              <a:spcAft>
+                <a:spcPts val="1200"/>
               </a:spcAft>
               <a:defRPr sz="1800">
                 <a:solidFill>
@@ -9794,22 +10217,7 @@
               </a:defRPr>
             </a:pPr>
             <a:r>
-              <a:t>•  2★ Rating = −1.0 (Mild dislike; penalizes genre)</a:t>
-            </a:r>
-          </a:p>
-          <a:p>
-            <a:pPr>
-              <a:spcAft>
-                <a:spcPts val="1000"/>
-              </a:spcAft>
-              <a:defRPr sz="1800">
-                <a:solidFill>
-                  <a:srgbClr val="E2E8F0"/>
-                </a:solidFill>
-              </a:defRPr>
-            </a:pPr>
-            <a:r>
-              <a:t>•  1★ Rating = −2.0 (Strongly avoided; heavy penalty)</a:t>
+              <a:t>•  Multi-Word Safety: Preserves compound genre tokens (e.g., 'martial arts', 'slice of life', 'sci-fi') accurately.</a:t>
             </a:r>
           </a:p>
         </p:txBody>
@@ -9833,7 +10241,7 @@
           </a:solidFill>
           <a:ln w="19050">
             <a:solidFill>
-              <a:srgbClr val="334155"/>
+              <a:srgbClr val="06B6D4"/>
             </a:solidFill>
           </a:ln>
         </p:spPr>
@@ -9883,16 +10291,31 @@
           <a:p>
             <a:pPr>
               <a:spcAft>
+                <a:spcPts val="1400"/>
+              </a:spcAft>
+              <a:defRPr sz="2400" b="1">
+                <a:solidFill>
+                  <a:srgbClr val="F8FAFC"/>
+                </a:solidFill>
+              </a:defRPr>
+            </a:pPr>
+            <a:r>
+              <a:t>Cosine Similarity Formulation</a:t>
+            </a:r>
+          </a:p>
+          <a:p>
+            <a:pPr>
+              <a:spcAft>
                 <a:spcPts val="1600"/>
               </a:spcAft>
-              <a:defRPr sz="2400" b="1">
-                <a:solidFill>
-                  <a:srgbClr val="F8FAFC"/>
-                </a:solidFill>
-              </a:defRPr>
-            </a:pPr>
-            <a:r>
-              <a:t>User Profile Construction</a:t>
+              <a:defRPr sz="2000" b="1">
+                <a:solidFill>
+                  <a:srgbClr val="06B6D4"/>
+                </a:solidFill>
+              </a:defRPr>
+            </a:pPr>
+            <a:r>
+              <a:t>sim(A, B) = ( A • B ) / ( ||A|| × ||B|| )</a:t>
             </a:r>
           </a:p>
           <a:p>
@@ -9907,7 +10330,7 @@
               </a:defRPr>
             </a:pPr>
             <a:r>
-              <a:t>•  Active Session Learning: Taste vector updates in real time immediately after each star rating is submitted.</a:t>
+              <a:t>•  Dot Product (A • B): Computes the exact count of shared overlapping genres between two titles.</a:t>
             </a:r>
           </a:p>
           <a:p>
@@ -9922,7 +10345,7 @@
               </a:defRPr>
             </a:pPr>
             <a:r>
-              <a:t>•  Non-Negative Preference (ReLU): Negative sums are clamped at 0 to maintain a positive genre preference magnitude.</a:t>
+              <a:t>•  Vector Norms (||A|| × ||B||): Normalizes score by vector lengths so titles with many genres do not artificially dominate.</a:t>
             </a:r>
           </a:p>
           <a:p>
@@ -9937,7 +10360,7 @@
               </a:defRPr>
             </a:pPr>
             <a:r>
-              <a:t>•  Candidate Ranking: Every unrated anime is scored against the normalized user vector via Cosine Similarity.</a:t>
+              <a:t>•  Standard Library: Implemented via sklearn.metrics.pairwise.cosine_similarity.</a:t>
             </a:r>
           </a:p>
           <a:p>
@@ -9952,7 +10375,7 @@
               </a:defRPr>
             </a:pPr>
             <a:r>
-              <a:t>•  High Precision: Delivers 0.5500 Precision@10, accurately targeting the viewer's favorite genre clusters.</a:t>
+              <a:t>•  Intuitive Range: Produces a clean similarity score from 0.00 (disjoint) to 1.00 (identical genre profile).</a:t>
             </a:r>
           </a:p>
         </p:txBody>
@@ -10049,7 +10472,7 @@
               </a:defRPr>
             </a:pPr>
             <a:r>
-              <a:t>RECOMMENDATION PARADIGM 3A</a:t>
+              <a:t>RECOMMENDATION PARADIGM 2B</a:t>
             </a:r>
           </a:p>
         </p:txBody>
@@ -10085,7 +10508,7 @@
               </a:defRPr>
             </a:pPr>
             <a:r>
-              <a:t>Knowledge-Based Decision Constraints</a:t>
+              <a:t>Reference Anime Matching &amp; Worked Example</a:t>
             </a:r>
           </a:p>
         </p:txBody>
@@ -10121,7 +10544,7 @@
               </a:defRPr>
             </a:pPr>
             <a:r>
-              <a:t>Evaluating user situation limits through hard constraint satisfaction.</a:t>
+              <a:t>User-selected reference item comparison with concrete mathematical step-by-step example.</a:t>
             </a:r>
           </a:p>
         </p:txBody>
@@ -10145,7 +10568,7 @@
           </a:solidFill>
           <a:ln w="19050">
             <a:solidFill>
-              <a:srgbClr val="06B6D4"/>
+              <a:srgbClr val="6366F1"/>
             </a:solidFill>
           </a:ln>
         </p:spPr>
@@ -10195,7 +10618,7 @@
           <a:p>
             <a:pPr>
               <a:spcAft>
-                <a:spcPts val="1600"/>
+                <a:spcPts val="1400"/>
               </a:spcAft>
               <a:defRPr sz="2400" b="1">
                 <a:solidFill>
@@ -10204,13 +10627,13 @@
               </a:defRPr>
             </a:pPr>
             <a:r>
-              <a:t>Explicit Hard Constraints</a:t>
-            </a:r>
-          </a:p>
-          <a:p>
-            <a:pPr>
-              <a:spcAft>
-                <a:spcPts val="1200"/>
+              <a:t>Reference-Item Matching Architecture</a:t>
+            </a:r>
+          </a:p>
+          <a:p>
+            <a:pPr>
+              <a:spcAft>
+                <a:spcPts val="1000"/>
               </a:spcAft>
               <a:defRPr sz="1800">
                 <a:solidFill>
@@ -10219,13 +10642,13 @@
               </a:defRPr>
             </a:pPr>
             <a:r>
-              <a:t>•  Episode Budget Limit: Candidate must have episodes ≤ user limit (e.g. ≤ 13 eps for a single evening).</a:t>
-            </a:r>
-          </a:p>
-          <a:p>
-            <a:pPr>
-              <a:spcAft>
-                <a:spcPts val="1200"/>
+              <a:t>•  Reference Selection: When user selects or rates Anime A (e.g. 5★), Anime A becomes the active reference anime.</a:t>
+            </a:r>
+          </a:p>
+          <a:p>
+            <a:pPr>
+              <a:spcAft>
+                <a:spcPts val="1000"/>
               </a:spcAft>
               <a:defRPr sz="1800">
                 <a:solidFill>
@@ -10234,13 +10657,13 @@
               </a:defRPr>
             </a:pPr>
             <a:r>
-              <a:t>•  Minimum Quality Threshold: Candidate must have viewer score ≥ user minimum (e.g. rating ≥ 4.0★).</a:t>
-            </a:r>
-          </a:p>
-          <a:p>
-            <a:pPr>
-              <a:spcAft>
-                <a:spcPts val="1200"/>
+              <a:t>•  No Rating Weighting: Rating indicates user selection/like; strictly avoids arbitrary Rating - 3.0 math.</a:t>
+            </a:r>
+          </a:p>
+          <a:p>
+            <a:pPr>
+              <a:spcAft>
+                <a:spcPts val="1000"/>
               </a:spcAft>
               <a:defRPr sz="1800">
                 <a:solidFill>
@@ -10249,13 +10672,13 @@
               </a:defRPr>
             </a:pPr>
             <a:r>
-              <a:t>•  Required Genres: Candidate must include all selected required genres (e.g. must include Sci-Fi).</a:t>
-            </a:r>
-          </a:p>
-          <a:p>
-            <a:pPr>
-              <a:spcAft>
-                <a:spcPts val="1200"/>
+              <a:t>•  Catalog Comparison: Anime A's genre vector is compared against all catalog titles via Cosine Similarity.</a:t>
+            </a:r>
+          </a:p>
+          <a:p>
+            <a:pPr>
+              <a:spcAft>
+                <a:spcPts val="1000"/>
               </a:spcAft>
               <a:defRPr sz="1800">
                 <a:solidFill>
@@ -10264,7 +10687,22 @@
               </a:defRPr>
             </a:pPr>
             <a:r>
-              <a:t>•  Excluded Genres: Candidate must NOT contain any forbidden genres (e.g. avoid Horror).</a:t>
+              <a:t>•  Self-Exclusion: The reference anime itself is strictly removed from the recommendation candidates.</a:t>
+            </a:r>
+          </a:p>
+          <a:p>
+            <a:pPr>
+              <a:spcAft>
+                <a:spcPts val="1000"/>
+              </a:spcAft>
+              <a:defRPr sz="1800">
+                <a:solidFill>
+                  <a:srgbClr val="E2E8F0"/>
+                </a:solidFill>
+              </a:defRPr>
+            </a:pPr>
+            <a:r>
+              <a:t>•  Top-N Ranking: Remaining anime are sorted in descending order of similarity score to return Top-N.</a:t>
             </a:r>
           </a:p>
         </p:txBody>
@@ -10288,7 +10726,7 @@
           </a:solidFill>
           <a:ln w="19050">
             <a:solidFill>
-              <a:srgbClr val="334155"/>
+              <a:srgbClr val="10B981"/>
             </a:solidFill>
           </a:ln>
         </p:spPr>
@@ -10338,7 +10776,7 @@
           <a:p>
             <a:pPr>
               <a:spcAft>
-                <a:spcPts val="1600"/>
+                <a:spcPts val="1200"/>
               </a:spcAft>
               <a:defRPr sz="2400" b="1">
                 <a:solidFill>
@@ -10347,13 +10785,13 @@
               </a:defRPr>
             </a:pPr>
             <a:r>
-              <a:t>Domain Knowledge Rules</a:t>
-            </a:r>
-          </a:p>
-          <a:p>
-            <a:pPr>
-              <a:spcAft>
-                <a:spcPts val="1200"/>
+              <a:t>Concrete Worked Example</a:t>
+            </a:r>
+          </a:p>
+          <a:p>
+            <a:pPr>
+              <a:spcAft>
+                <a:spcPts val="800"/>
               </a:spcAft>
               <a:defRPr sz="1800">
                 <a:solidFill>
@@ -10362,49 +10800,90 @@
               </a:defRPr>
             </a:pPr>
             <a:r>
-              <a:t>•  Viewing Commitment Rule: Categorizes anime length into clear commitment tiers:</a:t>
+              <a:t>•  Anime A = Action, Fantasy  •  Anime B = Action, Adventure</a:t>
+            </a:r>
+          </a:p>
+          <a:p>
+            <a:pPr>
+              <a:spcAft>
+                <a:spcPts val="800"/>
+              </a:spcAft>
+              <a:defRPr sz="1800">
+                <a:solidFill>
+                  <a:srgbClr val="E2E8F0"/>
+                </a:solidFill>
+              </a:defRPr>
+            </a:pPr>
+            <a:r>
+              <a:t>•  Anime C = Romance, Drama   •  Anime D = Action, Fantasy, Adv.</a:t>
+            </a:r>
+          </a:p>
+          <a:p>
+            <a:pPr>
+              <a:spcAft>
+                <a:spcPts val="800"/>
+              </a:spcAft>
+              <a:defRPr sz="1800">
+                <a:solidFill>
+                  <a:srgbClr val="E2E8F0"/>
+                </a:solidFill>
+              </a:defRPr>
+            </a:pPr>
+            <a:r>
+              <a:t>•  sim(A, B) = 1 / (√2 × √2) = 0.50</a:t>
+            </a:r>
+          </a:p>
+          <a:p>
+            <a:pPr>
+              <a:spcAft>
+                <a:spcPts val="800"/>
+              </a:spcAft>
+              <a:defRPr sz="1800">
+                <a:solidFill>
+                  <a:srgbClr val="E2E8F0"/>
+                </a:solidFill>
+              </a:defRPr>
+            </a:pPr>
+            <a:r>
+              <a:t>•  sim(A, C) = 0 / (√2 × √2) = 0.00</a:t>
+            </a:r>
+          </a:p>
+          <a:p>
+            <a:pPr>
+              <a:spcAft>
+                <a:spcPts val="800"/>
+              </a:spcAft>
+              <a:defRPr sz="1800">
+                <a:solidFill>
+                  <a:srgbClr val="E2E8F0"/>
+                </a:solidFill>
+              </a:defRPr>
+            </a:pPr>
+            <a:r>
+              <a:t>•  sim(A, D) = 2 / (√2 × √3) = 2 / 2.449 ≈ 0.82</a:t>
+            </a:r>
+          </a:p>
+          <a:p>
+            <a:pPr>
+              <a:spcAft>
+                <a:spcPts val="800"/>
+              </a:spcAft>
+              <a:defRPr sz="1800">
+                <a:solidFill>
+                  <a:srgbClr val="E2E8F0"/>
+                </a:solidFill>
+              </a:defRPr>
+            </a:pPr>
+            <a:r>
+              <a:t>•  Ranked Output for User Selecting Anime A:</a:t>
             </a:r>
             <a:br/>
             <a:r>
-              <a:t>   - Short: ≤ 13 episodes (quick finish)</a:t>
+              <a:t>  1. Anime D — Sim: 0.82 (Action, Fantasy, Adventure)</a:t>
             </a:r>
             <a:br/>
             <a:r>
-              <a:t>   - Medium: 14 to 26 episodes (weekend binge)</a:t>
-            </a:r>
-            <a:br/>
-            <a:r>
-              <a:t>   - Long: &gt; 26 episodes (extended series)</a:t>
-            </a:r>
-          </a:p>
-          <a:p>
-            <a:pPr>
-              <a:spcAft>
-                <a:spcPts val="1200"/>
-              </a:spcAft>
-              <a:defRPr sz="1800">
-                <a:solidFill>
-                  <a:srgbClr val="E2E8F0"/>
-                </a:solidFill>
-              </a:defRPr>
-            </a:pPr>
-            <a:r>
-              <a:t>•  Zero Past History Needed: Functions as an on-demand decision filter; works 100% on day one.</a:t>
-            </a:r>
-          </a:p>
-          <a:p>
-            <a:pPr>
-              <a:spcAft>
-                <a:spcPts val="1200"/>
-              </a:spcAft>
-              <a:defRPr sz="1800">
-                <a:solidFill>
-                  <a:srgbClr val="E2E8F0"/>
-                </a:solidFill>
-              </a:defRPr>
-            </a:pPr>
-            <a:r>
-              <a:t>•  High Utility Focus: Guarantees that every returned title strictly fits the user's available time.</a:t>
+              <a:t>  2. Anime B — Sim: 0.50 (Action, Adventure)</a:t>
             </a:r>
           </a:p>
         </p:txBody>

</xml_diff>